<commit_message>
feat(presentations): add LaTeX MathJax rendering pipeline and update week 2 deck
- Integrate mathjax-full and katex dependencies for headless math rendering
- Implement renderLatexToSvg helper with viewBox aspect ratio computation
- Update Slide 3 in generate_roadsense_week2_deck.js with 4-part mathematical breakdown
- Generate vector math assets in assets/generated_math/
- Rebuild RoadSense_Week2_Executive_Progress.pptx
</commit_message>
<xml_diff>
--- a/intel/presentations/decks/RoadSense_Week2_Executive_Progress.pptx
+++ b/intel/presentations/decks/RoadSense_Week2_Executive_Progress.pptx
@@ -2325,7 +2325,7 @@
                 <a:ea typeface="Segoe UI" pitchFamily="34" charset="-122"/>
                 <a:cs typeface="Segoe UI" pitchFamily="34" charset="-120"/>
               </a:rPr>
-              <a:t>STRATEGIC DIRECTION</a:t>
+              <a:t>STRATEGIC DIRECTION • PHASE 3</a:t>
             </a:r>
             <a:endParaRPr lang="en-US" sz="1000" dirty="0"/>
           </a:p>
@@ -2364,7 +2364,7 @@
                 <a:ea typeface="Segoe UI" pitchFamily="34" charset="-122"/>
                 <a:cs typeface="Segoe UI" pitchFamily="34" charset="-120"/>
               </a:rPr>
-              <a:t>The Road Ahead: On-Device Edge Perception &amp; Active Safety Alerts</a:t>
+              <a:t>Automated ML Validation &amp; Multi-Modal Sensor Fusion Engine</a:t>
             </a:r>
             <a:endParaRPr lang="en-US" sz="2000" dirty="0"/>
           </a:p>
@@ -2403,7 +2403,7 @@
                 <a:ea typeface="Segoe UI" pitchFamily="34" charset="-122"/>
                 <a:cs typeface="Segoe UI" pitchFamily="34" charset="-120"/>
               </a:rPr>
-              <a:t>Transitioning from multimodal dataset logging to real-time collision warning</a:t>
+              <a:t>Correlating camera ground truth with radar point clouds to train superior perception models</a:t>
             </a:r>
             <a:endParaRPr lang="en-US" sz="1150" dirty="0"/>
           </a:p>
@@ -2611,8 +2611,8 @@
         </p:nvSpPr>
         <p:spPr>
           <a:xfrm>
-            <a:off x="914400" y="1783080"/>
-            <a:ext cx="2971800" cy="4343400"/>
+            <a:off x="914400" y="1737360"/>
+            <a:ext cx="2971800" cy="4434840"/>
           </a:xfrm>
           <a:prstGeom prst="rect">
             <a:avLst/>
@@ -2636,14 +2636,29 @@
                 <a:ea typeface="Segoe UI" pitchFamily="34" charset="-122"/>
                 <a:cs typeface="Segoe UI" pitchFamily="34" charset="-120"/>
               </a:rPr>
-              <a:t>Pillar 1: Edge Object Detection
-</a:t>
-            </a:r>
-            <a:pPr indent="0" marL="0">
-              <a:buNone/>
-            </a:pPr>
-            <a:r>
-              <a:rPr lang="en-US" sz="1050" b="1" dirty="0">
+              <a:t>Pillar 1: Optical Ground Truth
+</a:t>
+            </a:r>
+            <a:pPr indent="0" marL="0">
+              <a:buNone/>
+            </a:pPr>
+            <a:r>
+              <a:rPr lang="en-US" sz="1000" b="1" dirty="0">
+                <a:solidFill>
+                  <a:srgbClr val="64748B"/>
+                </a:solidFill>
+                <a:latin typeface="Segoe UI" pitchFamily="34" charset="0"/>
+                <a:ea typeface="Segoe UI" pitchFamily="34" charset="-122"/>
+                <a:cs typeface="Segoe UI" pitchFamily="34" charset="-120"/>
+              </a:rPr>
+              <a:t>Vision-to-3D Road Inversion
+</a:t>
+            </a:r>
+            <a:pPr indent="0" marL="0">
+              <a:buNone/>
+            </a:pPr>
+            <a:r>
+              <a:rPr lang="en-US" sz="1000" b="1" dirty="0">
                 <a:solidFill>
                   <a:srgbClr val="0F172A"/>
                 </a:solidFill>
@@ -2651,14 +2666,14 @@
                 <a:ea typeface="Segoe UI" pitchFamily="34" charset="-122"/>
                 <a:cs typeface="Segoe UI" pitchFamily="34" charset="-120"/>
               </a:rPr>
-              <a:t>• Lightweight TFLite / YOLO-Nano:
-</a:t>
-            </a:r>
-            <a:pPr indent="0" marL="0">
-              <a:buNone/>
-            </a:pPr>
-            <a:r>
-              <a:rPr lang="en-US" sz="950" dirty="0">
+              <a:t>• Dense Semantic Detection:
+</a:t>
+            </a:r>
+            <a:pPr indent="0" marL="0">
+              <a:buNone/>
+            </a:pPr>
+            <a:r>
+              <a:rPr lang="en-US" sz="900" dirty="0">
                 <a:solidFill>
                   <a:srgbClr val="334155"/>
                 </a:solidFill>
@@ -2666,14 +2681,14 @@
                 <a:ea typeface="Segoe UI" pitchFamily="34" charset="-122"/>
                 <a:cs typeface="Segoe UI" pitchFamily="34" charset="-120"/>
               </a:rPr>
-              <a:t>  Deploy quantized mobile neural network directly onto smartphone NPU / GPU delegate.
-</a:t>
-            </a:r>
-            <a:pPr indent="0" marL="0">
-              <a:buNone/>
-            </a:pPr>
-            <a:r>
-              <a:rPr lang="en-US" sz="1050" b="1" dirty="0">
+              <a:t>  YOLOv8x/v11 detects dynamic vehicles (cars, motorcycles, auto-rickshaws, pedestrians) + road contact patches.
+</a:t>
+            </a:r>
+            <a:pPr indent="0" marL="0">
+              <a:buNone/>
+            </a:pPr>
+            <a:r>
+              <a:rPr lang="en-US" sz="1000" b="1" dirty="0">
                 <a:solidFill>
                   <a:srgbClr val="0F172A"/>
                 </a:solidFill>
@@ -2681,14 +2696,14 @@
                 <a:ea typeface="Segoe UI" pitchFamily="34" charset="-122"/>
                 <a:cs typeface="Segoe UI" pitchFamily="34" charset="-120"/>
               </a:rPr>
-              <a:t>• 30 FPS Real-Time Inference:
-</a:t>
-            </a:r>
-            <a:pPr indent="0" marL="0">
-              <a:buNone/>
-            </a:pPr>
-            <a:r>
-              <a:rPr lang="en-US" sz="950" dirty="0">
+              <a:t>• Road Boundary Segmentation:
+</a:t>
+            </a:r>
+            <a:pPr indent="0" marL="0">
+              <a:buNone/>
+            </a:pPr>
+            <a:r>
+              <a:rPr lang="en-US" sz="900" dirty="0">
                 <a:solidFill>
                   <a:srgbClr val="334155"/>
                 </a:solidFill>
@@ -2696,14 +2711,14 @@
                 <a:ea typeface="Segoe UI" pitchFamily="34" charset="-122"/>
                 <a:cs typeface="Segoe UI" pitchFamily="34" charset="-120"/>
               </a:rPr>
-              <a:t>  Zero latency penalty on Camera2 recording pipeline; asynchronous frame sampling.
-</a:t>
-            </a:r>
-            <a:pPr indent="0" marL="0">
-              <a:buNone/>
-            </a:pPr>
-            <a:r>
-              <a:rPr lang="en-US" sz="1050" b="1" dirty="0">
+              <a:t>  Segments drivable corridor, curbs, guardrails, and roadside clutter (signposts, trees, barriers).
+</a:t>
+            </a:r>
+            <a:pPr indent="0" marL="0">
+              <a:buNone/>
+            </a:pPr>
+            <a:r>
+              <a:rPr lang="en-US" sz="1000" b="1" dirty="0">
                 <a:solidFill>
                   <a:srgbClr val="0F172A"/>
                 </a:solidFill>
@@ -2711,14 +2726,14 @@
                 <a:ea typeface="Segoe UI" pitchFamily="34" charset="-122"/>
                 <a:cs typeface="Segoe UI" pitchFamily="34" charset="-120"/>
               </a:rPr>
-              <a:t>• 2D Bounding Box Extraction:
-</a:t>
-            </a:r>
-            <a:pPr indent="0" marL="0">
-              <a:buNone/>
-            </a:pPr>
-            <a:r>
-              <a:rPr lang="en-US" sz="950" dirty="0">
+              <a:t>• Inverse Pinhole Raycasting:
+</a:t>
+            </a:r>
+            <a:pPr indent="0" marL="0">
+              <a:buNone/>
+            </a:pPr>
+            <a:r>
+              <a:rPr lang="en-US" sz="900" dirty="0">
                 <a:solidFill>
                   <a:srgbClr val="334155"/>
                 </a:solidFill>
@@ -2726,14 +2741,14 @@
                 <a:ea typeface="Segoe UI" pitchFamily="34" charset="-122"/>
                 <a:cs typeface="Segoe UI" pitchFamily="34" charset="-120"/>
               </a:rPr>
-              <a:t>  Detect vehicles, motorcycles, auto-rickshaws, and pedestrians in camera pixel space.
-</a:t>
-            </a:r>
-            <a:pPr indent="0" marL="0">
-              <a:buNone/>
-            </a:pPr>
-            <a:r>
-              <a:rPr lang="en-US" sz="1050" b="1" dirty="0">
+              <a:t>  Projects bounding box road contacts onto ground plane (Z_road = 0) in closed form, calculating exact metric 3D positions (Xc, Yc, Zc).
+</a:t>
+            </a:r>
+            <a:pPr indent="0" marL="0">
+              <a:buNone/>
+            </a:pPr>
+            <a:r>
+              <a:rPr lang="en-US" sz="1000" b="1" dirty="0">
                 <a:solidFill>
                   <a:srgbClr val="0F172A"/>
                 </a:solidFill>
@@ -2741,14 +2756,14 @@
                 <a:ea typeface="Segoe UI" pitchFamily="34" charset="-122"/>
                 <a:cs typeface="Segoe UI" pitchFamily="34" charset="-120"/>
               </a:rPr>
-              <a:t>• Ground Plane Snapping:
-</a:t>
-            </a:r>
-            <a:pPr indent="0" marL="0">
-              <a:buNone/>
-            </a:pPr>
-            <a:r>
-              <a:rPr lang="en-US" sz="950" dirty="0">
+              <a:t>• Replaces ₹35L RTK-DGPS:
+</a:t>
+            </a:r>
+            <a:pPr indent="0" marL="0">
+              <a:buNone/>
+            </a:pPr>
+            <a:r>
+              <a:rPr lang="en-US" sz="900" dirty="0">
                 <a:solidFill>
                   <a:srgbClr val="334155"/>
                 </a:solidFill>
@@ -2756,7 +2771,37 @@
                 <a:ea typeface="Segoe UI" pitchFamily="34" charset="-122"/>
                 <a:cs typeface="Segoe UI" pitchFamily="34" charset="-120"/>
               </a:rPr>
-              <a:t>  Bottom edge of 2D bounding boxes projected onto 3D road plane for spatial fusion.</a:t>
+              <a:t>  Zero incremental hardware cost; establishes ground truth for all surrounding traffic in uncontrolled public driving.
+</a:t>
+            </a:r>
+            <a:pPr indent="0" marL="0">
+              <a:buNone/>
+            </a:pPr>
+            <a:r>
+              <a:rPr lang="en-US" sz="1000" b="1" dirty="0">
+                <a:solidFill>
+                  <a:srgbClr val="0F172A"/>
+                </a:solidFill>
+                <a:latin typeface="Segoe UI" pitchFamily="34" charset="0"/>
+                <a:ea typeface="Segoe UI" pitchFamily="34" charset="-122"/>
+                <a:cs typeface="Segoe UI" pitchFamily="34" charset="-120"/>
+              </a:rPr>
+              <a:t>• Output: vision_gt.json:
+</a:t>
+            </a:r>
+            <a:pPr indent="0" marL="0">
+              <a:buNone/>
+            </a:pPr>
+            <a:r>
+              <a:rPr lang="en-US" sz="900" dirty="0">
+                <a:solidFill>
+                  <a:srgbClr val="334155"/>
+                </a:solidFill>
+                <a:latin typeface="Segoe UI" pitchFamily="34" charset="0"/>
+                <a:ea typeface="Segoe UI" pitchFamily="34" charset="-122"/>
+                <a:cs typeface="Segoe UI" pitchFamily="34" charset="-120"/>
+              </a:rPr>
+              <a:t>  Microsecond synchronized 3D bounding boxes latched to session_timeline.csv.</a:t>
             </a:r>
             <a:endParaRPr lang="en-US" sz="1300" dirty="0"/>
           </a:p>
@@ -2797,8 +2842,8 @@
         </p:nvSpPr>
         <p:spPr>
           <a:xfrm>
-            <a:off x="4608576" y="1783080"/>
-            <a:ext cx="2971800" cy="4343400"/>
+            <a:off x="4608576" y="1737360"/>
+            <a:ext cx="2971800" cy="4434840"/>
           </a:xfrm>
           <a:prstGeom prst="rect">
             <a:avLst/>
@@ -2822,14 +2867,29 @@
                 <a:ea typeface="Segoe UI" pitchFamily="34" charset="-122"/>
                 <a:cs typeface="Segoe UI" pitchFamily="34" charset="-120"/>
               </a:rPr>
-              <a:t>Pillar 2: Multimodal EKF Fusion
-</a:t>
-            </a:r>
-            <a:pPr indent="0" marL="0">
-              <a:buNone/>
-            </a:pPr>
-            <a:r>
-              <a:rPr lang="en-US" sz="1050" b="1" dirty="0">
+              <a:t>Pillar 2: Point-Cloud Correlation
+</a:t>
+            </a:r>
+            <a:pPr indent="0" marL="0">
+              <a:buNone/>
+            </a:pPr>
+            <a:r>
+              <a:rPr lang="en-US" sz="1000" b="1" dirty="0">
+                <a:solidFill>
+                  <a:srgbClr val="64748B"/>
+                </a:solidFill>
+                <a:latin typeface="Segoe UI" pitchFamily="34" charset="0"/>
+                <a:ea typeface="Segoe UI" pitchFamily="34" charset="-122"/>
+                <a:cs typeface="Segoe UI" pitchFamily="34" charset="-120"/>
+              </a:rPr>
+              <a:t>Clutter vs. Target Discrepancy Mining
+</a:t>
+            </a:r>
+            <a:pPr indent="0" marL="0">
+              <a:buNone/>
+            </a:pPr>
+            <a:r>
+              <a:rPr lang="en-US" sz="1000" b="1" dirty="0">
                 <a:solidFill>
                   <a:srgbClr val="0F172A"/>
                 </a:solidFill>
@@ -2837,14 +2897,14 @@
                 <a:ea typeface="Segoe UI" pitchFamily="34" charset="-122"/>
                 <a:cs typeface="Segoe UI" pitchFamily="34" charset="-120"/>
               </a:rPr>
-              <a:t>• Extended Kalman Filter (EKF):
-</a:t>
-            </a:r>
-            <a:pPr indent="0" marL="0">
-              <a:buNone/>
-            </a:pPr>
-            <a:r>
-              <a:rPr lang="en-US" sz="950" dirty="0">
+              <a:t>• 6-DOF Spatial Alignment:
+</a:t>
+            </a:r>
+            <a:pPr indent="0" marL="0">
+              <a:buNone/>
+            </a:pPr>
+            <a:r>
+              <a:rPr lang="en-US" sz="900" dirty="0">
                 <a:solidFill>
                   <a:srgbClr val="334155"/>
                 </a:solidFill>
@@ -2852,14 +2912,14 @@
                 <a:ea typeface="Segoe UI" pitchFamily="34" charset="-122"/>
                 <a:cs typeface="Segoe UI" pitchFamily="34" charset="-120"/>
               </a:rPr>
-              <a:t>  Fuse radar range and Doppler range-rate with camera 2D azimuth and elevation angles.
-</a:t>
-            </a:r>
-            <a:pPr indent="0" marL="0">
-              <a:buNone/>
-            </a:pPr>
-            <a:r>
-              <a:rPr lang="en-US" sz="1050" b="1" dirty="0">
+              <a:t>  Uses calibrated [R|T] and K to project 3.125M radar point clouds and EKF tracks into camera pixel space.
+</a:t>
+            </a:r>
+            <a:pPr indent="0" marL="0">
+              <a:buNone/>
+            </a:pPr>
+            <a:r>
+              <a:rPr lang="en-US" sz="1000" b="1" dirty="0">
                 <a:solidFill>
                   <a:srgbClr val="0F172A"/>
                 </a:solidFill>
@@ -2867,14 +2927,14 @@
                 <a:ea typeface="Segoe UI" pitchFamily="34" charset="-122"/>
                 <a:cs typeface="Segoe UI" pitchFamily="34" charset="-120"/>
               </a:rPr>
-              <a:t>• Sensor Complementarity:
-</a:t>
-            </a:r>
-            <a:pPr indent="0" marL="0">
-              <a:buNone/>
-            </a:pPr>
-            <a:r>
-              <a:rPr lang="en-US" sz="950" dirty="0">
+              <a:t>• Noise vs. Vehicle Discrimination:
+</a:t>
+            </a:r>
+            <a:pPr indent="0" marL="0">
+              <a:buNone/>
+            </a:pPr>
+            <a:r>
+              <a:rPr lang="en-US" sz="900" dirty="0">
                 <a:solidFill>
                   <a:srgbClr val="334155"/>
                 </a:solidFill>
@@ -2882,14 +2942,14 @@
                 <a:ea typeface="Segoe UI" pitchFamily="34" charset="-122"/>
                 <a:cs typeface="Segoe UI" pitchFamily="34" charset="-120"/>
               </a:rPr>
-              <a:t>  Radar excels at depth &amp; speed (immune to rain/glare); Vision excels at lateral position &amp; classification.
-</a:t>
-            </a:r>
-            <a:pPr indent="0" marL="0">
-              <a:buNone/>
-            </a:pPr>
-            <a:r>
-              <a:rPr lang="en-US" sz="1050" b="1" dirty="0">
+              <a:t>  Correlates radar returns with optical objects to determine if reflections are genuine vehicles, multipath ghosts, or roadside clutter.
+</a:t>
+            </a:r>
+            <a:pPr indent="0" marL="0">
+              <a:buNone/>
+            </a:pPr>
+            <a:r>
+              <a:rPr lang="en-US" sz="1000" b="1" dirty="0">
                 <a:solidFill>
                   <a:srgbClr val="0F172A"/>
                 </a:solidFill>
@@ -2897,14 +2957,14 @@
                 <a:ea typeface="Segoe UI" pitchFamily="34" charset="-122"/>
                 <a:cs typeface="Segoe UI" pitchFamily="34" charset="-120"/>
               </a:rPr>
-              <a:t>• Track Persistence &amp; Gating:
-</a:t>
-            </a:r>
-            <a:pPr indent="0" marL="0">
-              <a:buNone/>
-            </a:pPr>
-            <a:r>
-              <a:rPr lang="en-US" sz="950" dirty="0">
+              <a:t>• Self-Supervised Disagreement Rules:
+</a:t>
+            </a:r>
+            <a:pPr indent="0" marL="0">
+              <a:buNone/>
+            </a:pPr>
+            <a:r>
+              <a:rPr lang="en-US" sz="850" dirty="0">
                 <a:solidFill>
                   <a:srgbClr val="334155"/>
                 </a:solidFill>
@@ -2912,14 +2972,29 @@
                 <a:ea typeface="Segoe UI" pitchFamily="34" charset="-122"/>
                 <a:cs typeface="Segoe UI" pitchFamily="34" charset="-120"/>
               </a:rPr>
-              <a:t>  Mahalanobis distance gating to prevent ghost association and maintain persistent track IDs.
-</a:t>
-            </a:r>
-            <a:pPr indent="0" marL="0">
-              <a:buNone/>
-            </a:pPr>
-            <a:r>
-              <a:rPr lang="en-US" sz="1050" b="1" dirty="0">
+              <a:t>  • Rule 1 (Phantom Ghost): Radar target present &amp; Camera void (multipath ground bounce under trucks/plates).
+</a:t>
+            </a:r>
+            <a:pPr indent="0" marL="0">
+              <a:buNone/>
+            </a:pPr>
+            <a:r>
+              <a:rPr lang="en-US" sz="850" dirty="0">
+                <a:solidFill>
+                  <a:srgbClr val="334155"/>
+                </a:solidFill>
+                <a:latin typeface="Segoe UI" pitchFamily="34" charset="0"/>
+                <a:ea typeface="Segoe UI" pitchFamily="34" charset="-122"/>
+                <a:cs typeface="Segoe UI" pitchFamily="34" charset="-120"/>
+              </a:rPr>
+              <a:t>  • Rule 2 (Radar Blindness): Camera target present &amp; Radar void (low-RCS plastic scooters, pedestrians).
+</a:t>
+            </a:r>
+            <a:pPr indent="0" marL="0">
+              <a:buNone/>
+            </a:pPr>
+            <a:r>
+              <a:rPr lang="en-US" sz="1000" b="1" dirty="0">
                 <a:solidFill>
                   <a:srgbClr val="0F172A"/>
                 </a:solidFill>
@@ -2927,14 +3002,14 @@
                 <a:ea typeface="Segoe UI" pitchFamily="34" charset="-122"/>
                 <a:cs typeface="Segoe UI" pitchFamily="34" charset="-120"/>
               </a:rPr>
-              <a:t>• Ego-Motion Compensation:
-</a:t>
-            </a:r>
-            <a:pPr indent="0" marL="0">
-              <a:buNone/>
-            </a:pPr>
-            <a:r>
-              <a:rPr lang="en-US" sz="950" dirty="0">
+              <a:t>• Human-in-the-Loop Active Learning:
+</a:t>
+            </a:r>
+            <a:pPr indent="0" marL="0">
+              <a:buNone/>
+            </a:pPr>
+            <a:r>
+              <a:rPr lang="en-US" sz="900" dirty="0">
                 <a:solidFill>
                   <a:srgbClr val="334155"/>
                 </a:solidFill>
@@ -2942,7 +3017,7 @@
                 <a:ea typeface="Segoe UI" pitchFamily="34" charset="-122"/>
                 <a:cs typeface="Segoe UI" pitchFamily="34" charset="-120"/>
               </a:rPr>
-              <a:t>  LSM6DSL yaw rate and IMU velocity dynamically subtracted from radar Doppler vectors.</a:t>
+              <a:t>  Extracts automated 5-second video triage clips (.mp4) for 1-click human verification of discrepant edge cases.</a:t>
             </a:r>
             <a:endParaRPr lang="en-US" sz="1300" dirty="0"/>
           </a:p>
@@ -2983,8 +3058,8 @@
         </p:nvSpPr>
         <p:spPr>
           <a:xfrm>
-            <a:off x="8302752" y="1783080"/>
-            <a:ext cx="2971800" cy="4343400"/>
+            <a:off x="8302752" y="1737360"/>
+            <a:ext cx="2971800" cy="4434840"/>
           </a:xfrm>
           <a:prstGeom prst="rect">
             <a:avLst/>
@@ -3008,14 +3083,29 @@
                 <a:ea typeface="Segoe UI" pitchFamily="34" charset="-122"/>
                 <a:cs typeface="Segoe UI" pitchFamily="34" charset="-120"/>
               </a:rPr>
-              <a:t>Pillar 3: Active Safety Warnings
-</a:t>
-            </a:r>
-            <a:pPr indent="0" marL="0">
-              <a:buNone/>
-            </a:pPr>
-            <a:r>
-              <a:rPr lang="en-US" sz="1050" b="1" dirty="0">
+              <a:t>Pillar 3: Fused Multimodal Model
+</a:t>
+            </a:r>
+            <a:pPr indent="0" marL="0">
+              <a:buNone/>
+            </a:pPr>
+            <a:r>
+              <a:rPr lang="en-US" sz="1000" b="1" dirty="0">
+                <a:solidFill>
+                  <a:srgbClr val="64748B"/>
+                </a:solidFill>
+                <a:latin typeface="Segoe UI" pitchFamily="34" charset="0"/>
+                <a:ea typeface="Segoe UI" pitchFamily="34" charset="-122"/>
+                <a:cs typeface="Segoe UI" pitchFamily="34" charset="-120"/>
+              </a:rPr>
+              <a:t>Surpassing Camera-Only Limits
+</a:t>
+            </a:r>
+            <a:pPr indent="0" marL="0">
+              <a:buNone/>
+            </a:pPr>
+            <a:r>
+              <a:rPr lang="en-US" sz="1000" b="1" dirty="0">
                 <a:solidFill>
                   <a:srgbClr val="0F172A"/>
                 </a:solidFill>
@@ -3023,14 +3113,14 @@
                 <a:ea typeface="Segoe UI" pitchFamily="34" charset="-122"/>
                 <a:cs typeface="Segoe UI" pitchFamily="34" charset="-120"/>
               </a:rPr>
-              <a:t>• Forward Collision Warning (FCW):
-</a:t>
-            </a:r>
-            <a:pPr indent="0" marL="0">
-              <a:buNone/>
-            </a:pPr>
-            <a:r>
-              <a:rPr lang="en-US" sz="950" dirty="0">
+              <a:t>• Cross-Modal Sensor Synergy:
+</a:t>
+            </a:r>
+            <a:pPr indent="0" marL="0">
+              <a:buNone/>
+            </a:pPr>
+            <a:r>
+              <a:rPr lang="en-US" sz="900" dirty="0">
                 <a:solidFill>
                   <a:srgbClr val="334155"/>
                 </a:solidFill>
@@ -3038,14 +3128,14 @@
                 <a:ea typeface="Segoe UI" pitchFamily="34" charset="-122"/>
                 <a:cs typeface="Segoe UI" pitchFamily="34" charset="-120"/>
               </a:rPr>
-              <a:t>  Compute Time-to-Collision (TTC = Range / -RangeRate). Trigger audio-visual alerts when TTC &lt; 2.5s.
-</a:t>
-            </a:r>
-            <a:pPr indent="0" marL="0">
-              <a:buNone/>
-            </a:pPr>
-            <a:r>
-              <a:rPr lang="en-US" sz="1050" b="1" dirty="0">
+              <a:t>  Trains a multimodal network fusing radar Doppler velocity and metric depth with camera high-resolution visual semantics.
+</a:t>
+            </a:r>
+            <a:pPr indent="0" marL="0">
+              <a:buNone/>
+            </a:pPr>
+            <a:r>
+              <a:rPr lang="en-US" sz="1000" b="1" dirty="0">
                 <a:solidFill>
                   <a:srgbClr val="0F172A"/>
                 </a:solidFill>
@@ -3053,14 +3143,14 @@
                 <a:ea typeface="Segoe UI" pitchFamily="34" charset="-122"/>
                 <a:cs typeface="Segoe UI" pitchFamily="34" charset="-120"/>
               </a:rPr>
-              <a:t>• Blind Spot Detection (BSD):
-</a:t>
-            </a:r>
-            <a:pPr indent="0" marL="0">
-              <a:buNone/>
-            </a:pPr>
-            <a:r>
-              <a:rPr lang="en-US" sz="950" dirty="0">
+              <a:t>• Surpasses Camera-Only Baseline:
+</a:t>
+            </a:r>
+            <a:pPr indent="0" marL="0">
+              <a:buNone/>
+            </a:pPr>
+            <a:r>
+              <a:rPr lang="en-US" sz="850" dirty="0">
                 <a:solidFill>
                   <a:srgbClr val="334155"/>
                 </a:solidFill>
@@ -3068,14 +3158,29 @@
                 <a:ea typeface="Segoe UI" pitchFamily="34" charset="-122"/>
                 <a:cs typeface="Segoe UI" pitchFamily="34" charset="-120"/>
               </a:rPr>
-              <a:t>  Radar boundary monitoring in adjacent lane zones (lateral 1.5m to 4.5m, setback -5m to +2m).
-</a:t>
-            </a:r>
-            <a:pPr indent="0" marL="0">
-              <a:buNone/>
-            </a:pPr>
-            <a:r>
-              <a:rPr lang="en-US" sz="1050" b="1" dirty="0">
+              <a:t>  • Maintains tracking during heavy monsoon rain, thick fog, direct sun glare, and pitch darkness.
+</a:t>
+            </a:r>
+            <a:pPr indent="0" marL="0">
+              <a:buNone/>
+            </a:pPr>
+            <a:r>
+              <a:rPr lang="en-US" sz="850" dirty="0">
+                <a:solidFill>
+                  <a:srgbClr val="334155"/>
+                </a:solidFill>
+                <a:latin typeface="Segoe UI" pitchFamily="34" charset="0"/>
+                <a:ea typeface="Segoe UI" pitchFamily="34" charset="-122"/>
+                <a:cs typeface="Segoe UI" pitchFamily="34" charset="-120"/>
+              </a:rPr>
+              <a:t>  • Resolves camera long-range pitch errors (±18m error at &gt;60m resolved by direct radar range).
+</a:t>
+            </a:r>
+            <a:pPr indent="0" marL="0">
+              <a:buNone/>
+            </a:pPr>
+            <a:r>
+              <a:rPr lang="en-US" sz="1000" b="1" dirty="0">
                 <a:solidFill>
                   <a:srgbClr val="0F172A"/>
                 </a:solidFill>
@@ -3083,14 +3188,14 @@
                 <a:ea typeface="Segoe UI" pitchFamily="34" charset="-122"/>
                 <a:cs typeface="Segoe UI" pitchFamily="34" charset="-120"/>
               </a:rPr>
-              <a:t>• Cockpit HUD Warning Overlays:
-</a:t>
-            </a:r>
-            <a:pPr indent="0" marL="0">
-              <a:buNone/>
-            </a:pPr>
-            <a:r>
-              <a:rPr lang="en-US" sz="950" dirty="0">
+              <a:t>• Automated Reference Laboratory:
+</a:t>
+            </a:r>
+            <a:pPr indent="0" marL="0">
+              <a:buNone/>
+            </a:pPr>
+            <a:r>
+              <a:rPr lang="en-US" sz="900" dirty="0">
                 <a:solidFill>
                   <a:srgbClr val="334155"/>
                 </a:solidFill>
@@ -3098,14 +3203,14 @@
                 <a:ea typeface="Segoe UI" pitchFamily="34" charset="-122"/>
                 <a:cs typeface="Segoe UI" pitchFamily="34" charset="-120"/>
               </a:rPr>
-              <a:t>  Red visual warning halos and audible vehicle speaker chimes on high-priority collision vectors.
-</a:t>
-            </a:r>
-            <a:pPr indent="0" marL="0">
-              <a:buNone/>
-            </a:pPr>
-            <a:r>
-              <a:rPr lang="en-US" sz="1050" b="1" dirty="0">
+              <a:t>  The trained model serves as the automated ground truth validator, eliminating hundreds of manual video review hours.
+</a:t>
+            </a:r>
+            <a:pPr indent="0" marL="0">
+              <a:buNone/>
+            </a:pPr>
+            <a:r>
+              <a:rPr lang="en-US" sz="1000" b="1" dirty="0">
                 <a:solidFill>
                   <a:srgbClr val="0F172A"/>
                 </a:solidFill>
@@ -3113,14 +3218,14 @@
                 <a:ea typeface="Segoe UI" pitchFamily="34" charset="-122"/>
                 <a:cs typeface="Segoe UI" pitchFamily="34" charset="-120"/>
               </a:rPr>
-              <a:t>• Event Tagging &amp; Highlight Export:
-</a:t>
-            </a:r>
-            <a:pPr indent="0" marL="0">
-              <a:buNone/>
-            </a:pPr>
-            <a:r>
-              <a:rPr lang="en-US" sz="950" dirty="0">
+              <a:t>• CLEAR MOT &amp; ISO 15623 Benchmarking:
+</a:t>
+            </a:r>
+            <a:pPr indent="0" marL="0">
+              <a:buNone/>
+            </a:pPr>
+            <a:r>
+              <a:rPr lang="en-US" sz="900" dirty="0">
                 <a:solidFill>
                   <a:srgbClr val="334155"/>
                 </a:solidFill>
@@ -3128,7 +3233,7 @@
                 <a:ea typeface="Segoe UI" pitchFamily="34" charset="-122"/>
                 <a:cs typeface="Segoe UI" pitchFamily="34" charset="-120"/>
               </a:rPr>
-              <a:t>  Automatically tag near-miss events in MCAP and session_timeline.csv for fleet safety analysis.</a:t>
+              <a:t>  Automated calculation of MOTA, MOTP, IDF1, and active safety pass/fail compliance scorecards.</a:t>
             </a:r>
             <a:endParaRPr lang="en-US" sz="1300" dirty="0"/>
           </a:p>
@@ -3199,7 +3304,7 @@
                 <a:ea typeface="Segoe UI" pitchFamily="34" charset="-122"/>
                 <a:cs typeface="Segoe UI" pitchFamily="34" charset="-120"/>
               </a:rPr>
-              <a:t>PROJECT HANDOVER</a:t>
+              <a:t>PROJECT HANDOVER &amp; ROADMAP</a:t>
             </a:r>
             <a:endParaRPr lang="en-US" sz="1000" dirty="0"/>
           </a:p>
@@ -3238,7 +3343,7 @@
                 <a:ea typeface="Segoe UI" pitchFamily="34" charset="-122"/>
                 <a:cs typeface="Segoe UI" pitchFamily="34" charset="-120"/>
               </a:rPr>
-              <a:t>Consolidated Milestones &amp; Immediate Action Items</a:t>
+              <a:t>Milestone Handover: Phases 1 &amp; 2 Complete, Phase 3 Launch</a:t>
             </a:r>
             <a:endParaRPr lang="en-US" sz="2000" dirty="0"/>
           </a:p>
@@ -3277,7 +3382,7 @@
                 <a:ea typeface="Segoe UI" pitchFamily="34" charset="-122"/>
                 <a:cs typeface="Segoe UI" pitchFamily="34" charset="-120"/>
               </a:rPr>
-              <a:t>Summary of Week 2 deliverables and execution plan for Week 3</a:t>
+              <a:t>Consolidating on-device perception breakthroughs and launching the validation pipeline</a:t>
             </a:r>
             <a:endParaRPr lang="en-US" sz="1150" dirty="0"/>
           </a:p>
@@ -3485,8 +3590,8 @@
         </p:nvSpPr>
         <p:spPr>
           <a:xfrm>
-            <a:off x="914400" y="1783080"/>
-            <a:ext cx="4800600" cy="4343400"/>
+            <a:off x="914400" y="1737360"/>
+            <a:ext cx="4800600" cy="4434840"/>
           </a:xfrm>
           <a:prstGeom prst="rect">
             <a:avLst/>
@@ -3510,14 +3615,29 @@
                 <a:ea typeface="Segoe UI" pitchFamily="34" charset="-122"/>
                 <a:cs typeface="Segoe UI" pitchFamily="34" charset="-120"/>
               </a:rPr>
-              <a:t>Sprint 2 Key Accomplishments
-</a:t>
-            </a:r>
-            <a:pPr indent="0" marL="0">
-              <a:buNone/>
-            </a:pPr>
-            <a:r>
-              <a:rPr lang="en-US" sz="1050" b="1" dirty="0">
+              <a:t>Sprint 2 Deliverables: 100% Complete
+</a:t>
+            </a:r>
+            <a:pPr indent="0" marL="0">
+              <a:buNone/>
+            </a:pPr>
+            <a:r>
+              <a:rPr lang="en-US" sz="1000" b="1" dirty="0">
+                <a:solidFill>
+                  <a:srgbClr val="64748B"/>
+                </a:solidFill>
+                <a:latin typeface="Segoe UI" pitchFamily="34" charset="0"/>
+                <a:ea typeface="Segoe UI" pitchFamily="34" charset="-122"/>
+                <a:cs typeface="Segoe UI" pitchFamily="34" charset="-120"/>
+              </a:rPr>
+              <a:t>On-Device Perception, Kinematics &amp; Toolchain Foundation
+</a:t>
+            </a:r>
+            <a:pPr indent="0" marL="0">
+              <a:buNone/>
+            </a:pPr>
+            <a:r>
+              <a:rPr lang="en-US" sz="1000" b="1" dirty="0">
                 <a:solidFill>
                   <a:srgbClr val="0F172A"/>
                 </a:solidFill>
@@ -3525,14 +3645,14 @@
                 <a:ea typeface="Segoe UI" pitchFamily="34" charset="-122"/>
                 <a:cs typeface="Segoe UI" pitchFamily="34" charset="-120"/>
               </a:rPr>
-              <a:t>1. 6-DOF Spatial Calibration Complete:
-</a:t>
-            </a:r>
-            <a:pPr indent="0" marL="0">
-              <a:buNone/>
-            </a:pPr>
-            <a:r>
-              <a:rPr lang="en-US" sz="950" dirty="0">
+              <a:t>1. Phase 1: 6-DOF Spatial Calibration Complete (✅):
+</a:t>
+            </a:r>
+            <a:pPr indent="0" marL="0">
+              <a:buNone/>
+            </a:pPr>
+            <a:r>
+              <a:rPr lang="en-US" sz="900" dirty="0">
                 <a:solidFill>
                   <a:srgbClr val="334155"/>
                 </a:solidFill>
@@ -3540,14 +3660,14 @@
                 <a:ea typeface="Segoe UI" pitchFamily="34" charset="-122"/>
                 <a:cs typeface="Segoe UI" pitchFamily="34" charset="-120"/>
               </a:rPr>
-              <a:t>   • Full [R|T] extrinsics and Camera2 K matrix operational.
-</a:t>
-            </a:r>
-            <a:pPr indent="0" marL="0">
-              <a:buNone/>
-            </a:pPr>
-            <a:r>
-              <a:rPr lang="en-US" sz="950" dirty="0">
+              <a:t>   • Full [R|T] extrinsics and Camera2 K intrinsics operational.
+</a:t>
+            </a:r>
+            <a:pPr indent="0" marL="0">
+              <a:buNone/>
+            </a:pPr>
+            <a:r>
+              <a:rPr lang="en-US" sz="900" dirty="0">
                 <a:solidFill>
                   <a:srgbClr val="334155"/>
                 </a:solidFill>
@@ -3555,14 +3675,14 @@
                 <a:ea typeface="Segoe UI" pitchFamily="34" charset="-122"/>
                 <a:cs typeface="Segoe UI" pitchFamily="34" charset="-120"/>
               </a:rPr>
-              <a:t>   • Reverse Touch Solver snaps pitch/yaw in &lt;60 seconds.
-</a:t>
-            </a:r>
-            <a:pPr indent="0" marL="0">
-              <a:buNone/>
-            </a:pPr>
-            <a:r>
-              <a:rPr lang="en-US" sz="1050" b="1" dirty="0">
+              <a:t>   • Reverse Touch Solver (O(1)) snaps pitch/yaw in &lt;60 seconds without calibration rigs.
+</a:t>
+            </a:r>
+            <a:pPr indent="0" marL="0">
+              <a:buNone/>
+            </a:pPr>
+            <a:r>
+              <a:rPr lang="en-US" sz="1000" b="1" dirty="0">
                 <a:solidFill>
                   <a:srgbClr val="0F172A"/>
                 </a:solidFill>
@@ -3570,14 +3690,14 @@
                 <a:ea typeface="Segoe UI" pitchFamily="34" charset="-122"/>
                 <a:cs typeface="Segoe UI" pitchFamily="34" charset="-120"/>
               </a:rPr>
-              <a:t>2. RViz-Inspired Radar Overlays:
-</a:t>
-            </a:r>
-            <a:pPr indent="0" marL="0">
-              <a:buNone/>
-            </a:pPr>
-            <a:r>
-              <a:rPr lang="en-US" sz="950" dirty="0">
+              <a:t>2. Phase 2: Live Viewfinder Overlays Complete (✅):
+</a:t>
+            </a:r>
+            <a:pPr indent="0" marL="0">
+              <a:buNone/>
+            </a:pPr>
+            <a:r>
+              <a:rPr lang="en-US" sz="900" dirty="0">
                 <a:solidFill>
                   <a:srgbClr val="334155"/>
                 </a:solidFill>
@@ -3585,14 +3705,14 @@
                 <a:ea typeface="Segoe UI" pitchFamily="34" charset="-122"/>
                 <a:cs typeface="Segoe UI" pitchFamily="34" charset="-120"/>
               </a:rPr>
-              <a:t>   • 12-segment road contact footprints and vertical stems solve depth ambiguity.
-</a:t>
-            </a:r>
-            <a:pPr indent="0" marL="0">
-              <a:buNone/>
-            </a:pPr>
-            <a:r>
-              <a:rPr lang="en-US" sz="950" dirty="0">
+              <a:t>   • RViz-inspired hybrid radar lollipops with 12-segment road contact footprints and vertical stems.
+</a:t>
+            </a:r>
+            <a:pPr indent="0" marL="0">
+              <a:buNone/>
+            </a:pPr>
+            <a:r>
+              <a:rPr lang="en-US" sz="900" dirty="0">
                 <a:solidFill>
                   <a:srgbClr val="334155"/>
                 </a:solidFill>
@@ -3600,14 +3720,14 @@
                 <a:ea typeface="Segoe UI" pitchFamily="34" charset="-122"/>
                 <a:cs typeface="Segoe UI" pitchFamily="34" charset="-120"/>
               </a:rPr>
-              <a:t>   • Staggered distance range rings render seamlessly in live viewfinder.
-</a:t>
-            </a:r>
-            <a:pPr indent="0" marL="0">
-              <a:buNone/>
-            </a:pPr>
-            <a:r>
-              <a:rPr lang="en-US" sz="1050" b="1" dirty="0">
+              <a:t>   • Painter's algorithm depth-sorting (sortByDescending) &amp; staggered range rings (10m–120m).
+</a:t>
+            </a:r>
+            <a:pPr indent="0" marL="0">
+              <a:buNone/>
+            </a:pPr>
+            <a:r>
+              <a:rPr lang="en-US" sz="1000" b="1" dirty="0">
                 <a:solidFill>
                   <a:srgbClr val="0F172A"/>
                 </a:solidFill>
@@ -3615,14 +3735,14 @@
                 <a:ea typeface="Segoe UI" pitchFamily="34" charset="-122"/>
                 <a:cs typeface="Segoe UI" pitchFamily="34" charset="-120"/>
               </a:rPr>
-              <a:t>3. 100 Hz LSM6DSL Kinematics:
-</a:t>
-            </a:r>
-            <a:pPr indent="0" marL="0">
-              <a:buNone/>
-            </a:pPr>
-            <a:r>
-              <a:rPr lang="en-US" sz="950" dirty="0">
+              <a:t>3. 100 Hz LSM6DSL Vehicle Kinematics (✅):
+</a:t>
+            </a:r>
+            <a:pPr indent="0" marL="0">
+              <a:buNone/>
+            </a:pPr>
+            <a:r>
+              <a:rPr lang="en-US" sz="900" dirty="0">
                 <a:solidFill>
                   <a:srgbClr val="334155"/>
                 </a:solidFill>
@@ -3630,14 +3750,29 @@
                 <a:ea typeface="Segoe UI" pitchFamily="34" charset="-122"/>
                 <a:cs typeface="Segoe UI" pitchFamily="34" charset="-120"/>
               </a:rPr>
-              <a:t>   • Gravity-free linear acceleration and magnetic-immune 6-DOF orientation.
-</a:t>
-            </a:r>
-            <a:pPr indent="0" marL="0">
-              <a:buNone/>
-            </a:pPr>
-            <a:r>
-              <a:rPr lang="en-US" sz="950" dirty="0">
+              <a:t>   • Gravity-free linear acceleration &amp; magnetic-immune 6-DOF orientation with sub-2ms jitter.
+</a:t>
+            </a:r>
+            <a:pPr indent="0" marL="0">
+              <a:buNone/>
+            </a:pPr>
+            <a:r>
+              <a:rPr lang="en-US" sz="1000" b="1" dirty="0">
+                <a:solidFill>
+                  <a:srgbClr val="0F172A"/>
+                </a:solidFill>
+                <a:latin typeface="Segoe UI" pitchFamily="34" charset="0"/>
+                <a:ea typeface="Segoe UI" pitchFamily="34" charset="-122"/>
+                <a:cs typeface="Segoe UI" pitchFamily="34" charset="-120"/>
+              </a:rPr>
+              <a:t>4. High-Throughput Desktop Toolchain (✅):
+</a:t>
+            </a:r>
+            <a:pPr indent="0" marL="0">
+              <a:buNone/>
+            </a:pPr>
+            <a:r>
+              <a:rPr lang="en-US" sz="900" dirty="0">
                 <a:solidFill>
                   <a:srgbClr val="334155"/>
                 </a:solidFill>
@@ -3645,14 +3780,29 @@
                 <a:ea typeface="Segoe UI" pitchFamily="34" charset="-122"/>
                 <a:cs typeface="Segoe UI" pitchFamily="34" charset="-120"/>
               </a:rPr>
-              <a:t>   • Sub-2ms inter-frame jitter verified via monotonic hardware clock.
-</a:t>
-            </a:r>
-            <a:pPr indent="0" marL="0">
-              <a:buNone/>
-            </a:pPr>
-            <a:r>
-              <a:rPr lang="en-US" sz="1050" b="1" dirty="0">
+              <a:t>   • Zero-dependency web dashboard (:8088) with real-time SSE progress streaming.
+</a:t>
+            </a:r>
+            <a:pPr indent="0" marL="0">
+              <a:buNone/>
+            </a:pPr>
+            <a:r>
+              <a:rPr lang="en-US" sz="900" dirty="0">
+                <a:solidFill>
+                  <a:srgbClr val="334155"/>
+                </a:solidFill>
+                <a:latin typeface="Segoe UI" pitchFamily="34" charset="0"/>
+                <a:ea typeface="Segoe UI" pitchFamily="34" charset="-122"/>
+                <a:cs typeface="Segoe UI" pitchFamily="34" charset="-120"/>
+              </a:rPr>
+              <a:t>   • Zero-cost MCAP demuxing at &gt;11,500 FPS with embedded RoadSense_Cockpit_Layout.json.
+</a:t>
+            </a:r>
+            <a:pPr indent="0" marL="0">
+              <a:buNone/>
+            </a:pPr>
+            <a:r>
+              <a:rPr lang="en-US" sz="1000" b="1" dirty="0">
                 <a:solidFill>
                   <a:srgbClr val="0F172A"/>
                 </a:solidFill>
@@ -3660,14 +3810,14 @@
                 <a:ea typeface="Segoe UI" pitchFamily="34" charset="-122"/>
                 <a:cs typeface="Segoe UI" pitchFamily="34" charset="-120"/>
               </a:rPr>
-              <a:t>4. High-Throughput Desktop Toolchain:
-</a:t>
-            </a:r>
-            <a:pPr indent="0" marL="0">
-              <a:buNone/>
-            </a:pPr>
-            <a:r>
-              <a:rPr lang="en-US" sz="950" dirty="0">
+              <a:t>5. Production Engineering Hardening (✅):
+</a:t>
+            </a:r>
+            <a:pPr indent="0" marL="0">
+              <a:buNone/>
+            </a:pPr>
+            <a:r>
+              <a:rPr lang="en-US" sz="900" dirty="0">
                 <a:solidFill>
                   <a:srgbClr val="334155"/>
                 </a:solidFill>
@@ -3675,52 +3825,7 @@
                 <a:ea typeface="Segoe UI" pitchFamily="34" charset="-122"/>
                 <a:cs typeface="Segoe UI" pitchFamily="34" charset="-120"/>
               </a:rPr>
-              <a:t>   • Zero-dependency web dashboard (:8088) with real-time SSE progress.
-</a:t>
-            </a:r>
-            <a:pPr indent="0" marL="0">
-              <a:buNone/>
-            </a:pPr>
-            <a:r>
-              <a:rPr lang="en-US" sz="950" dirty="0">
-                <a:solidFill>
-                  <a:srgbClr val="334155"/>
-                </a:solidFill>
-                <a:latin typeface="Segoe UI" pitchFamily="34" charset="0"/>
-                <a:ea typeface="Segoe UI" pitchFamily="34" charset="-122"/>
-                <a:cs typeface="Segoe UI" pitchFamily="34" charset="-120"/>
-              </a:rPr>
-              <a:t>   • Zero-cost MCAP video demuxing at &gt;11,500 FPS (~3.4s, 0% GPU load).
-</a:t>
-            </a:r>
-            <a:pPr indent="0" marL="0">
-              <a:buNone/>
-            </a:pPr>
-            <a:r>
-              <a:rPr lang="en-US" sz="1050" b="1" dirty="0">
-                <a:solidFill>
-                  <a:srgbClr val="0F172A"/>
-                </a:solidFill>
-                <a:latin typeface="Segoe UI" pitchFamily="34" charset="0"/>
-                <a:ea typeface="Segoe UI" pitchFamily="34" charset="-122"/>
-                <a:cs typeface="Segoe UI" pitchFamily="34" charset="-120"/>
-              </a:rPr>
-              <a:t>5. Production Engineering Hardening:
-</a:t>
-            </a:r>
-            <a:pPr indent="0" marL="0">
-              <a:buNone/>
-            </a:pPr>
-            <a:r>
-              <a:rPr lang="en-US" sz="950" dirty="0">
-                <a:solidFill>
-                  <a:srgbClr val="334155"/>
-                </a:solidFill>
-                <a:latin typeface="Segoe UI" pitchFamily="34" charset="0"/>
-                <a:ea typeface="Segoe UI" pitchFamily="34" charset="-122"/>
-                <a:cs typeface="Segoe UI" pitchFamily="34" charset="-120"/>
-              </a:rPr>
-              <a:t>   • Bugs #11 to #15 diagnosed and permanently eliminated; 24/24 unit tests passing.</a:t>
+              <a:t>   • Bugs #11 to #15 diagnosed and permanently eliminated; 24/24 JVM unit tests passing clean.</a:t>
             </a:r>
             <a:endParaRPr lang="en-US" sz="1300" dirty="0"/>
           </a:p>
@@ -3761,8 +3866,8 @@
         </p:nvSpPr>
         <p:spPr>
           <a:xfrm>
-            <a:off x="6473952" y="1783080"/>
-            <a:ext cx="4800600" cy="4343400"/>
+            <a:off x="6473952" y="1737360"/>
+            <a:ext cx="4800600" cy="4434840"/>
           </a:xfrm>
           <a:prstGeom prst="rect">
             <a:avLst/>
@@ -3786,14 +3891,29 @@
                 <a:ea typeface="Segoe UI" pitchFamily="34" charset="-122"/>
                 <a:cs typeface="Segoe UI" pitchFamily="34" charset="-120"/>
               </a:rPr>
-              <a:t>Immediate Action Items &amp; Week 3 Sprint
-</a:t>
-            </a:r>
-            <a:pPr indent="0" marL="0">
-              <a:buNone/>
-            </a:pPr>
-            <a:r>
-              <a:rPr lang="en-US" sz="1050" b="1" dirty="0">
+              <a:t>Phase 3 Sprint Action Plan
+</a:t>
+            </a:r>
+            <a:pPr indent="0" marL="0">
+              <a:buNone/>
+            </a:pPr>
+            <a:r>
+              <a:rPr lang="en-US" sz="1000" b="1" dirty="0">
+                <a:solidFill>
+                  <a:srgbClr val="64748B"/>
+                </a:solidFill>
+                <a:latin typeface="Segoe UI" pitchFamily="34" charset="0"/>
+                <a:ea typeface="Segoe UI" pitchFamily="34" charset="-122"/>
+                <a:cs typeface="Segoe UI" pitchFamily="34" charset="-120"/>
+              </a:rPr>
+              <a:t>Automated ML Validation &amp; Dataset Engine
+</a:t>
+            </a:r>
+            <a:pPr indent="0" marL="0">
+              <a:buNone/>
+            </a:pPr>
+            <a:r>
+              <a:rPr lang="en-US" sz="1000" b="1" dirty="0">
                 <a:solidFill>
                   <a:srgbClr val="0F172A"/>
                 </a:solidFill>
@@ -3801,14 +3921,14 @@
                 <a:ea typeface="Segoe UI" pitchFamily="34" charset="-122"/>
                 <a:cs typeface="Segoe UI" pitchFamily="34" charset="-120"/>
               </a:rPr>
-              <a:t>1. Vehicle Test Track Verification:
-</a:t>
-            </a:r>
-            <a:pPr indent="0" marL="0">
-              <a:buNone/>
-            </a:pPr>
-            <a:r>
-              <a:rPr lang="en-US" sz="950" dirty="0">
+              <a:t>1. Offline Optical 3D Raycaster Engine (vision_gt.json):
+</a:t>
+            </a:r>
+            <a:pPr indent="0" marL="0">
+              <a:buNone/>
+            </a:pPr>
+            <a:r>
+              <a:rPr lang="en-US" sz="900" dirty="0">
                 <a:solidFill>
                   <a:srgbClr val="334155"/>
                 </a:solidFill>
@@ -3816,14 +3936,14 @@
                 <a:ea typeface="Segoe UI" pitchFamily="34" charset="-122"/>
                 <a:cs typeface="Segoe UI" pitchFamily="34" charset="-120"/>
               </a:rPr>
-              <a:t>   • Validate 6-DOF Reverse Touch Solver across 5 varied vehicle mounting heights and windshield rake angles on the Bajaj test track.
-</a:t>
-            </a:r>
-            <a:pPr indent="0" marL="0">
-              <a:buNone/>
-            </a:pPr>
-            <a:r>
-              <a:rPr lang="en-US" sz="1050" b="1" dirty="0">
+              <a:t>   • Deploy YOLOv8x/v11 on recorded drive sessions to extract 2D vehicle bounding boxes and road plane contact patches (Z_road = 0).
+</a:t>
+            </a:r>
+            <a:pPr indent="0" marL="0">
+              <a:buNone/>
+            </a:pPr>
+            <a:r>
+              <a:rPr lang="en-US" sz="1000" b="1" dirty="0">
                 <a:solidFill>
                   <a:srgbClr val="0F172A"/>
                 </a:solidFill>
@@ -3831,14 +3951,14 @@
                 <a:ea typeface="Segoe UI" pitchFamily="34" charset="-122"/>
                 <a:cs typeface="Segoe UI" pitchFamily="34" charset="-120"/>
               </a:rPr>
-              <a:t>2. Extended Drive Cycle Thermal Validation:
-</a:t>
-            </a:r>
-            <a:pPr indent="0" marL="0">
-              <a:buNone/>
-            </a:pPr>
-            <a:r>
-              <a:rPr lang="en-US" sz="950" dirty="0">
+              <a:t>2. Radar Point-Cloud &amp; Clutter Correlator:
+</a:t>
+            </a:r>
+            <a:pPr indent="0" marL="0">
+              <a:buNone/>
+            </a:pPr>
+            <a:r>
+              <a:rPr lang="en-US" sz="900" dirty="0">
                 <a:solidFill>
                   <a:srgbClr val="334155"/>
                 </a:solidFill>
@@ -3846,14 +3966,14 @@
                 <a:ea typeface="Segoe UI" pitchFamily="34" charset="-122"/>
                 <a:cs typeface="Segoe UI" pitchFamily="34" charset="-120"/>
               </a:rPr>
-              <a:t>   • Execute continuous 60-minute logging runs under high ambient heat (38°C+) to benchmark sustained 100 Hz IMU jitter and Camera2 thermals.
-</a:t>
-            </a:r>
-            <a:pPr indent="0" marL="0">
-              <a:buNone/>
-            </a:pPr>
-            <a:r>
-              <a:rPr lang="en-US" sz="1050" b="1" dirty="0">
+              <a:t>   • Correlate radar reflections against optical objects to separate valid vehicle tracks from noise bursts and roadside clutter.
+</a:t>
+            </a:r>
+            <a:pPr indent="0" marL="0">
+              <a:buNone/>
+            </a:pPr>
+            <a:r>
+              <a:rPr lang="en-US" sz="1000" b="1" dirty="0">
                 <a:solidFill>
                   <a:srgbClr val="0F172A"/>
                 </a:solidFill>
@@ -3861,14 +3981,14 @@
                 <a:ea typeface="Segoe UI" pitchFamily="34" charset="-122"/>
                 <a:cs typeface="Segoe UI" pitchFamily="34" charset="-120"/>
               </a:rPr>
-              <a:t>3. TFLite Edge Perception Pipeline:
-</a:t>
-            </a:r>
-            <a:pPr indent="0" marL="0">
-              <a:buNone/>
-            </a:pPr>
-            <a:r>
-              <a:rPr lang="en-US" sz="950" dirty="0">
+              <a:t>3. Autonomous Discrepancy Mining Pipeline:
+</a:t>
+            </a:r>
+            <a:pPr indent="0" marL="0">
+              <a:buNone/>
+            </a:pPr>
+            <a:r>
+              <a:rPr lang="en-US" sz="900" dirty="0">
                 <a:solidFill>
                   <a:srgbClr val="334155"/>
                 </a:solidFill>
@@ -3876,14 +3996,14 @@
                 <a:ea typeface="Segoe UI" pitchFamily="34" charset="-122"/>
                 <a:cs typeface="Segoe UI" pitchFamily="34" charset="-120"/>
               </a:rPr>
-              <a:t>   • Integrate quantized YOLOv8-nano model on Android NNAPI/GPU delegate for 30 FPS vehicle and pedestrian bounding box detection.
-</a:t>
-            </a:r>
-            <a:pPr indent="0" marL="0">
-              <a:buNone/>
-            </a:pPr>
-            <a:r>
-              <a:rPr lang="en-US" sz="1050" b="1" dirty="0">
+              <a:t>   • Implement Rules 1–3 to automatically flag phantom radar ghosts and low-RCS blindness into 5-second video triage clips.
+</a:t>
+            </a:r>
+            <a:pPr indent="0" marL="0">
+              <a:buNone/>
+            </a:pPr>
+            <a:r>
+              <a:rPr lang="en-US" sz="1000" b="1" dirty="0">
                 <a:solidFill>
                   <a:srgbClr val="0F172A"/>
                 </a:solidFill>
@@ -3891,14 +4011,14 @@
                 <a:ea typeface="Segoe UI" pitchFamily="34" charset="-122"/>
                 <a:cs typeface="Segoe UI" pitchFamily="34" charset="-120"/>
               </a:rPr>
-              <a:t>4. Multimodal EKF Tracker Development:
-</a:t>
-            </a:r>
-            <a:pPr indent="0" marL="0">
-              <a:buNone/>
-            </a:pPr>
-            <a:r>
-              <a:rPr lang="en-US" sz="950" dirty="0">
+              <a:t>4. Active Learning Web Triage Interface:
+</a:t>
+            </a:r>
+            <a:pPr indent="0" marL="0">
+              <a:buNone/>
+            </a:pPr>
+            <a:r>
+              <a:rPr lang="en-US" sz="900" dirty="0">
                 <a:solidFill>
                   <a:srgbClr val="334155"/>
                 </a:solidFill>
@@ -3906,14 +4026,44 @@
                 <a:ea typeface="Segoe UI" pitchFamily="34" charset="-122"/>
                 <a:cs typeface="Segoe UI" pitchFamily="34" charset="-120"/>
               </a:rPr>
-              <a:t>   • Implement Kotlin Extended Kalman Filter fusing radar Doppler velocity with vision bounding box centroids.
-</a:t>
-            </a:r>
-            <a:pPr indent="0" marL="0">
-              <a:buNone/>
-            </a:pPr>
-            <a:r>
-              <a:rPr lang="en-US" sz="1200" b="1" dirty="0">
+              <a:t>   • Stand up a 1-click review module on the local Web Dashboard (localhost:8088) for rapid human verification of mined edge cases.
+</a:t>
+            </a:r>
+            <a:pPr indent="0" marL="0">
+              <a:buNone/>
+            </a:pPr>
+            <a:r>
+              <a:rPr lang="en-US" sz="1000" b="1" dirty="0">
+                <a:solidFill>
+                  <a:srgbClr val="0F172A"/>
+                </a:solidFill>
+                <a:latin typeface="Segoe UI" pitchFamily="34" charset="0"/>
+                <a:ea typeface="Segoe UI" pitchFamily="34" charset="-122"/>
+                <a:cs typeface="Segoe UI" pitchFamily="34" charset="-120"/>
+              </a:rPr>
+              <a:t>5. Train Multimodal Benchmark Fusion Model:
+</a:t>
+            </a:r>
+            <a:pPr indent="0" marL="0">
+              <a:buNone/>
+            </a:pPr>
+            <a:r>
+              <a:rPr lang="en-US" sz="900" dirty="0">
+                <a:solidFill>
+                  <a:srgbClr val="334155"/>
+                </a:solidFill>
+                <a:latin typeface="Segoe UI" pitchFamily="34" charset="0"/>
+                <a:ea typeface="Segoe UI" pitchFamily="34" charset="-122"/>
+                <a:cs typeface="Segoe UI" pitchFamily="34" charset="-120"/>
+              </a:rPr>
+              <a:t>   • Train the fused radar-vision network to automate fleet validation and generate automated CLEAR MOT scorecards.
+</a:t>
+            </a:r>
+            <a:pPr indent="0" marL="0">
+              <a:buNone/>
+            </a:pPr>
+            <a:r>
+              <a:rPr lang="en-US" sz="1100" b="1" dirty="0">
                 <a:solidFill>
                   <a:srgbClr val="15803D"/>
                 </a:solidFill>
@@ -4946,7 +5096,7 @@
                 <a:ea typeface="Segoe UI" pitchFamily="34" charset="-122"/>
                 <a:cs typeface="Segoe UI" pitchFamily="34" charset="-120"/>
               </a:rPr>
-              <a:t>SPATIAL FUSION</a:t>
+              <a:t>PERCEPTION &amp; SENSOR FUSION ENGINEERING</a:t>
             </a:r>
             <a:endParaRPr lang="en-US" sz="1000" dirty="0"/>
           </a:p>
@@ -4985,7 +5135,7 @@
                 <a:ea typeface="Segoe UI" pitchFamily="34" charset="-122"/>
                 <a:cs typeface="Segoe UI" pitchFamily="34" charset="-120"/>
               </a:rPr>
-              <a:t>60-Second In-Situ Extrinsic Calibration Engine</a:t>
+              <a:t>6-DOF Spatial Calibration &amp; Perspective Projection Math</a:t>
             </a:r>
             <a:endParaRPr lang="en-US" sz="2000" dirty="0"/>
           </a:p>
@@ -5024,7 +5174,7 @@
                 <a:ea typeface="Segoe UI" pitchFamily="34" charset="-122"/>
                 <a:cs typeface="Segoe UI" pitchFamily="34" charset="-120"/>
               </a:rPr>
-              <a:t>Solving mounting pitch and yaw in closed form (O(1)) without calibration rigs</a:t>
+              <a:t>Rigorous mathematical formulation for cross-sensor extrinsic alignment and closed-form angular recovery</a:t>
             </a:r>
             <a:endParaRPr lang="en-US" sz="1150" dirty="0"/>
           </a:p>
@@ -5205,12 +5355,12 @@
         </p:nvSpPr>
         <p:spPr>
           <a:xfrm>
-            <a:off x="731520" y="1600200"/>
-            <a:ext cx="5166360" cy="4709160"/>
+            <a:off x="731520" y="1417320"/>
+            <a:ext cx="5257800" cy="4937760"/>
           </a:xfrm>
           <a:prstGeom prst="roundRect">
             <a:avLst>
-              <a:gd name="adj" fmla="val 1165"/>
+              <a:gd name="adj" fmla="val 1111"/>
             </a:avLst>
           </a:prstGeom>
           <a:solidFill>
@@ -5232,8 +5382,8 @@
         </p:nvSpPr>
         <p:spPr>
           <a:xfrm>
-            <a:off x="914400" y="1783080"/>
-            <a:ext cx="4800600" cy="4343400"/>
+            <a:off x="914400" y="1581912"/>
+            <a:ext cx="4892040" cy="868680"/>
           </a:xfrm>
           <a:prstGeom prst="rect">
             <a:avLst/>
@@ -5249,7 +5399,7 @@
               <a:buNone/>
             </a:pPr>
             <a:r>
-              <a:rPr lang="en-US" sz="1300" b="1" dirty="0">
+              <a:rPr lang="en-US" sz="1100" b="1" dirty="0">
                 <a:solidFill>
                   <a:srgbClr val="1D4ED8"/>
                 </a:solidFill>
@@ -5257,14 +5407,14 @@
                 <a:ea typeface="Segoe UI" pitchFamily="34" charset="-122"/>
                 <a:cs typeface="Segoe UI" pitchFamily="34" charset="-120"/>
               </a:rPr>
-              <a:t>Closed-Form Mathematical Reverse Touch Solver
-</a:t>
-            </a:r>
-            <a:pPr indent="0" marL="0">
-              <a:buNone/>
-            </a:pPr>
-            <a:r>
-              <a:rPr lang="en-US" sz="1050" b="1" dirty="0">
+              <a:t>1. Coordinate Frame Conventions:
+</a:t>
+            </a:r>
+            <a:pPr indent="0" marL="0">
+              <a:buNone/>
+            </a:pPr>
+            <a:r>
+              <a:rPr lang="en-US" sz="950" b="1" dirty="0">
                 <a:solidFill>
                   <a:srgbClr val="0F172A"/>
                 </a:solidFill>
@@ -5272,14 +5422,13 @@
                 <a:ea typeface="Segoe UI" pitchFamily="34" charset="-122"/>
                 <a:cs typeface="Segoe UI" pitchFamily="34" charset="-120"/>
               </a:rPr>
-              <a:t>1. 6-DOF Rigid Body Transformation [ R | T ]:
-</a:t>
-            </a:r>
-            <a:pPr indent="0" marL="0">
-              <a:buNone/>
-            </a:pPr>
-            <a:r>
-              <a:rPr lang="en-US" sz="950" dirty="0">
+              <a:t>   • Radar Frame {R}: </a:t>
+            </a:r>
+            <a:pPr indent="0" marL="0">
+              <a:buNone/>
+            </a:pPr>
+            <a:r>
+              <a:rPr lang="en-US" sz="900" dirty="0">
                 <a:solidFill>
                   <a:srgbClr val="334155"/>
                 </a:solidFill>
@@ -5287,14 +5436,28 @@
                 <a:ea typeface="Segoe UI" pitchFamily="34" charset="-122"/>
                 <a:cs typeface="Segoe UI" pitchFamily="34" charset="-120"/>
               </a:rPr>
-              <a:t>   • Extrinsics specify 3D baseline: Lateral offset ΔX, Setback ΔY, Height ΔZ.
-</a:t>
-            </a:r>
-            <a:pPr indent="0" marL="0">
-              <a:buNone/>
-            </a:pPr>
-            <a:r>
-              <a:rPr lang="en-US" sz="950" dirty="0">
+              <a:t>+X_R = Right,  +Y_R = Forward (boresight),  +Z_R = Up.
+</a:t>
+            </a:r>
+            <a:pPr indent="0" marL="0">
+              <a:buNone/>
+            </a:pPr>
+            <a:r>
+              <a:rPr lang="en-US" sz="950" b="1" dirty="0">
+                <a:solidFill>
+                  <a:srgbClr val="0F172A"/>
+                </a:solidFill>
+                <a:latin typeface="Segoe UI" pitchFamily="34" charset="0"/>
+                <a:ea typeface="Segoe UI" pitchFamily="34" charset="-122"/>
+                <a:cs typeface="Segoe UI" pitchFamily="34" charset="-120"/>
+              </a:rPr>
+              <a:t>   • Camera Optical Frame {C}: </a:t>
+            </a:r>
+            <a:pPr indent="0" marL="0">
+              <a:buNone/>
+            </a:pPr>
+            <a:r>
+              <a:rPr lang="en-US" sz="900" dirty="0">
                 <a:solidFill>
                   <a:srgbClr val="334155"/>
                 </a:solidFill>
@@ -5302,176 +5465,411 @@
                 <a:ea typeface="Segoe UI" pitchFamily="34" charset="-122"/>
                 <a:cs typeface="Segoe UI" pitchFamily="34" charset="-120"/>
               </a:rPr>
-              <a:t>   • Rotation matrix parameterized by Pitch (θ), Yaw (ψ), and Roll (φ).
-</a:t>
-            </a:r>
-            <a:pPr indent="0" marL="0">
-              <a:buNone/>
-            </a:pPr>
-            <a:r>
-              <a:rPr lang="en-US" sz="1050" b="1" dirty="0">
-                <a:solidFill>
-                  <a:srgbClr val="0F172A"/>
-                </a:solidFill>
-                <a:latin typeface="Segoe UI" pitchFamily="34" charset="0"/>
-                <a:ea typeface="Segoe UI" pitchFamily="34" charset="-122"/>
-                <a:cs typeface="Segoe UI" pitchFamily="34" charset="-120"/>
-              </a:rPr>
-              <a:t>2. Camera Intrinsics Matrix (K):
-</a:t>
-            </a:r>
-            <a:pPr indent="0" marL="0">
-              <a:buNone/>
-            </a:pPr>
-            <a:r>
-              <a:rPr lang="en-US" sz="950" dirty="0">
-                <a:solidFill>
-                  <a:srgbClr val="334155"/>
-                </a:solidFill>
-                <a:latin typeface="Segoe UI" pitchFamily="34" charset="0"/>
-                <a:ea typeface="Segoe UI" pitchFamily="34" charset="-122"/>
-                <a:cs typeface="Segoe UI" pitchFamily="34" charset="-120"/>
-              </a:rPr>
-              <a:t>   • Automatically queried from CameraCharacteristics (LENS_INTRINSIC_CALIBRATION).
-</a:t>
-            </a:r>
-            <a:pPr indent="0" marL="0">
-              <a:buNone/>
-            </a:pPr>
-            <a:r>
-              <a:rPr lang="en-US" sz="950" dirty="0">
-                <a:solidFill>
-                  <a:srgbClr val="334155"/>
-                </a:solidFill>
-                <a:latin typeface="Segoe UI" pitchFamily="34" charset="0"/>
-                <a:ea typeface="Segoe UI" pitchFamily="34" charset="-122"/>
-                <a:cs typeface="Segoe UI" pitchFamily="34" charset="-120"/>
-              </a:rPr>
-              <a:t>   • Focal lengths (fx, fy) and optical principal center (cx, cy) mapped to preview.
-</a:t>
-            </a:r>
-            <a:pPr indent="0" marL="0">
-              <a:buNone/>
-            </a:pPr>
-            <a:r>
-              <a:rPr lang="en-US" sz="1050" b="1" dirty="0">
-                <a:solidFill>
-                  <a:srgbClr val="0F172A"/>
-                </a:solidFill>
-                <a:latin typeface="Segoe UI" pitchFamily="34" charset="0"/>
-                <a:ea typeface="Segoe UI" pitchFamily="34" charset="-122"/>
-                <a:cs typeface="Segoe UI" pitchFamily="34" charset="-120"/>
-              </a:rPr>
-              <a:t>3. Closed-Form Angle Recovery (O(1)):
-</a:t>
-            </a:r>
-            <a:pPr indent="0" marL="0">
-              <a:buNone/>
-            </a:pPr>
-            <a:r>
-              <a:rPr lang="en-US" sz="950" dirty="0">
-                <a:solidFill>
-                  <a:srgbClr val="334155"/>
-                </a:solidFill>
-                <a:latin typeface="Segoe UI" pitchFamily="34" charset="0"/>
-                <a:ea typeface="Segoe UI" pitchFamily="34" charset="-122"/>
-                <a:cs typeface="Segoe UI" pitchFamily="34" charset="-120"/>
-              </a:rPr>
-              <a:t>   • Given a known radar target at forward range R and tap pixel (u, v):
-</a:t>
-            </a:r>
-            <a:pPr indent="0" marL="0">
-              <a:buNone/>
-            </a:pPr>
-            <a:r>
-              <a:rPr lang="en-US" sz="950" b="1" dirty="0">
-                <a:solidFill>
-                  <a:srgbClr val="1D4ED8"/>
-                </a:solidFill>
-                <a:latin typeface="Consolas" pitchFamily="34" charset="0"/>
-                <a:ea typeface="Consolas" pitchFamily="34" charset="-122"/>
-                <a:cs typeface="Consolas" pitchFamily="34" charset="-120"/>
-              </a:rPr>
-              <a:t>     u_norm = (u - cx) / fx    |    v_norm = (v - cy) / fy
-</a:t>
-            </a:r>
-            <a:pPr indent="0" marL="0">
-              <a:buNone/>
-            </a:pPr>
-            <a:r>
-              <a:rPr lang="en-US" sz="950" b="1" dirty="0">
-                <a:solidFill>
-                  <a:srgbClr val="1D4ED8"/>
-                </a:solidFill>
-                <a:latin typeface="Consolas" pitchFamily="34" charset="0"/>
-                <a:ea typeface="Consolas" pitchFamily="34" charset="-122"/>
-                <a:cs typeface="Consolas" pitchFamily="34" charset="-120"/>
-              </a:rPr>
-              <a:t>     pitch_solved = -atan(v_norm)    |    yaw_solved = atan(u_norm)
-</a:t>
-            </a:r>
-            <a:pPr indent="0" marL="0">
-              <a:buNone/>
-            </a:pPr>
-            <a:r>
-              <a:rPr lang="en-US" sz="950" dirty="0">
-                <a:solidFill>
-                  <a:srgbClr val="334155"/>
-                </a:solidFill>
-                <a:latin typeface="Segoe UI" pitchFamily="34" charset="0"/>
-                <a:ea typeface="Segoe UI" pitchFamily="34" charset="-122"/>
-                <a:cs typeface="Segoe UI" pitchFamily="34" charset="-120"/>
-              </a:rPr>
-              <a:t>   • Solves pitch and yaw instantaneously without iterative gradient descent or non-linear optimization loops.
-</a:t>
-            </a:r>
-            <a:pPr indent="0" marL="0">
-              <a:buNone/>
-            </a:pPr>
-            <a:r>
-              <a:rPr lang="en-US" sz="1050" b="1" dirty="0">
-                <a:solidFill>
-                  <a:srgbClr val="0F172A"/>
-                </a:solidFill>
-                <a:latin typeface="Segoe UI" pitchFamily="34" charset="0"/>
-                <a:ea typeface="Segoe UI" pitchFamily="34" charset="-122"/>
-                <a:cs typeface="Segoe UI" pitchFamily="34" charset="-120"/>
-              </a:rPr>
-              <a:t>4. Single-Tap Snap Workflow:
-</a:t>
-            </a:r>
-            <a:pPr indent="0" marL="0">
-              <a:buNone/>
-            </a:pPr>
-            <a:r>
-              <a:rPr lang="en-US" sz="950" dirty="0">
-                <a:solidFill>
-                  <a:srgbClr val="334155"/>
-                </a:solidFill>
-                <a:latin typeface="Segoe UI" pitchFamily="34" charset="0"/>
-                <a:ea typeface="Segoe UI" pitchFamily="34" charset="-122"/>
-                <a:cs typeface="Segoe UI" pitchFamily="34" charset="-120"/>
-              </a:rPr>
-              <a:t>   • In-situ technician taps vehicle center in viewfinder; system locks calibration in &lt;60s.</a:t>
-            </a:r>
-            <a:endParaRPr lang="en-US" sz="1300" dirty="0"/>
+              <a:t>+X_C = Right,  +Y_C = Down,  +Z_C = Optical Depth (Forward).</a:t>
+            </a:r>
+            <a:endParaRPr lang="en-US" sz="1100" dirty="0"/>
           </a:p>
         </p:txBody>
       </p:sp>
       <p:sp>
         <p:nvSpPr>
-          <p:cNvPr id="12" name="Shape 10"/>
-          <p:cNvSpPr/>
-          <p:nvPr/>
-        </p:nvSpPr>
-        <p:spPr>
-          <a:xfrm>
-            <a:off x="6291072" y="1600200"/>
-            <a:ext cx="5166360" cy="4709160"/>
+          <p:cNvPr id="12" name="Text 10"/>
+          <p:cNvSpPr/>
+          <p:nvPr/>
+        </p:nvSpPr>
+        <p:spPr>
+          <a:xfrm>
+            <a:off x="914400" y="2514600"/>
+            <a:ext cx="4892040" cy="548640"/>
+          </a:xfrm>
+          <a:prstGeom prst="rect">
+            <a:avLst/>
+          </a:prstGeom>
+          <a:noFill/>
+          <a:ln/>
+        </p:spPr>
+        <p:txBody>
+          <a:bodyPr wrap="square" lIns="0" tIns="0" rIns="0" bIns="0" rtlCol="0" anchor="t"/>
+          <a:lstStyle/>
+          <a:p>
+            <a:pPr indent="0" marL="0">
+              <a:buNone/>
+            </a:pPr>
+            <a:r>
+              <a:rPr lang="en-US" sz="1100" b="1" dirty="0">
+                <a:solidFill>
+                  <a:srgbClr val="1D4ED8"/>
+                </a:solidFill>
+                <a:latin typeface="Segoe UI" pitchFamily="34" charset="0"/>
+                <a:ea typeface="Segoe UI" pitchFamily="34" charset="-122"/>
+                <a:cs typeface="Segoe UI" pitchFamily="34" charset="-120"/>
+              </a:rPr>
+              <a:t>2. Translation &amp; Axis Transformation:
+</a:t>
+            </a:r>
+            <a:pPr indent="0" marL="0">
+              <a:buNone/>
+            </a:pPr>
+            <a:r>
+              <a:rPr lang="en-US" sz="900" dirty="0">
+                <a:solidFill>
+                  <a:srgbClr val="334155"/>
+                </a:solidFill>
+                <a:latin typeface="Segoe UI" pitchFamily="34" charset="0"/>
+                <a:ea typeface="Segoe UI" pitchFamily="34" charset="-122"/>
+                <a:cs typeface="Segoe UI" pitchFamily="34" charset="-120"/>
+              </a:rPr>
+              <a:t>A point </a:t>
+            </a:r>
+            <a:pPr indent="0" marL="0">
+              <a:buNone/>
+            </a:pPr>
+            <a:r>
+              <a:rPr lang="en-US" sz="900" b="1" dirty="0">
+                <a:solidFill>
+                  <a:srgbClr val="0F172A"/>
+                </a:solidFill>
+                <a:latin typeface="Segoe UI" pitchFamily="34" charset="0"/>
+                <a:ea typeface="Segoe UI" pitchFamily="34" charset="-122"/>
+                <a:cs typeface="Segoe UI" pitchFamily="34" charset="-120"/>
+              </a:rPr>
+              <a:t>P_R = [X_R, Y_R, Z_R]^T</a:t>
+            </a:r>
+            <a:pPr indent="0" marL="0">
+              <a:buNone/>
+            </a:pPr>
+            <a:r>
+              <a:rPr lang="en-US" sz="900" dirty="0">
+                <a:solidFill>
+                  <a:srgbClr val="334155"/>
+                </a:solidFill>
+                <a:latin typeface="Segoe UI" pitchFamily="34" charset="0"/>
+                <a:ea typeface="Segoe UI" pitchFamily="34" charset="-122"/>
+                <a:cs typeface="Segoe UI" pitchFamily="34" charset="-120"/>
+              </a:rPr>
+              <a:t> is translated by physical lever-arm offset </a:t>
+            </a:r>
+            <a:pPr indent="0" marL="0">
+              <a:buNone/>
+            </a:pPr>
+            <a:r>
+              <a:rPr lang="en-US" sz="900" b="1" dirty="0">
+                <a:solidFill>
+                  <a:srgbClr val="0F172A"/>
+                </a:solidFill>
+                <a:latin typeface="Segoe UI" pitchFamily="34" charset="0"/>
+                <a:ea typeface="Segoe UI" pitchFamily="34" charset="-122"/>
+                <a:cs typeface="Segoe UI" pitchFamily="34" charset="-120"/>
+              </a:rPr>
+              <a:t>T</a:t>
+            </a:r>
+            <a:pPr indent="0" marL="0">
+              <a:buNone/>
+            </a:pPr>
+            <a:r>
+              <a:rPr lang="en-US" sz="900" dirty="0">
+                <a:solidFill>
+                  <a:srgbClr val="334155"/>
+                </a:solidFill>
+                <a:latin typeface="Segoe UI" pitchFamily="34" charset="0"/>
+                <a:ea typeface="Segoe UI" pitchFamily="34" charset="-122"/>
+                <a:cs typeface="Segoe UI" pitchFamily="34" charset="-120"/>
+              </a:rPr>
+              <a:t> and rotated by Euler angles (pitch θ, yaw ψ, roll φ):</a:t>
+            </a:r>
+            <a:endParaRPr lang="en-US" sz="1100" dirty="0"/>
+          </a:p>
+        </p:txBody>
+      </p:sp>
+      <p:pic>
+        <p:nvPicPr>
+          <p:cNvPr id="13" name="Image 0" descr="C:\Users\rakadu1.AHEAD\AndroidStudioProjects\RoadSense\intel\presentations\assets\generated_math\eq_p_vehicle.svg">    </p:cNvPr>
+          <p:cNvPicPr>
+            <a:picLocks noChangeAspect="1"/>
+          </p:cNvPicPr>
+          <p:nvPr/>
+        </p:nvPicPr>
+        <p:blipFill>
+          <a:blip r:embed="rId1">
+            <a:extLst>
+              <a:ext uri="{96DAC541-7B7A-43D3-8B79-37D633B846F1}">
+                <asvg:svgBlip xmlns:asvg="http://schemas.microsoft.com/office/drawing/2016/SVG/main" r:embed="rId2"/>
+              </a:ext>
+            </a:extLst>
+          </a:blip>
+          <a:stretch>
+            <a:fillRect/>
+          </a:stretch>
+        </p:blipFill>
+        <p:spPr>
+          <a:xfrm>
+            <a:off x="1623060" y="3108960"/>
+            <a:ext cx="3474720" cy="287795"/>
+          </a:xfrm>
+          <a:prstGeom prst="rect">
+            <a:avLst/>
+          </a:prstGeom>
+        </p:spPr>
+      </p:pic>
+      <p:sp>
+        <p:nvSpPr>
+          <p:cNvPr id="14" name="Text 11"/>
+          <p:cNvSpPr/>
+          <p:nvPr/>
+        </p:nvSpPr>
+        <p:spPr>
+          <a:xfrm>
+            <a:off x="914400" y="3520440"/>
+            <a:ext cx="4892040" cy="365760"/>
+          </a:xfrm>
+          <a:prstGeom prst="rect">
+            <a:avLst/>
+          </a:prstGeom>
+          <a:noFill/>
+          <a:ln/>
+        </p:spPr>
+        <p:txBody>
+          <a:bodyPr wrap="square" lIns="0" tIns="0" rIns="0" bIns="0" rtlCol="0" anchor="t"/>
+          <a:lstStyle/>
+          <a:p>
+            <a:pPr indent="0" marL="0">
+              <a:buNone/>
+            </a:pPr>
+            <a:r>
+              <a:rPr lang="en-US" sz="900" dirty="0">
+                <a:solidFill>
+                  <a:srgbClr val="334155"/>
+                </a:solidFill>
+                <a:latin typeface="Segoe UI" pitchFamily="34" charset="0"/>
+                <a:ea typeface="Segoe UI" pitchFamily="34" charset="-122"/>
+                <a:cs typeface="Segoe UI" pitchFamily="34" charset="-120"/>
+              </a:rPr>
+              <a:t>To align the vehicle/radar axes into camera optical frame {C}, we apply the permutation matrix </a:t>
+            </a:r>
+            <a:pPr indent="0" marL="0">
+              <a:buNone/>
+            </a:pPr>
+            <a:r>
+              <a:rPr lang="en-US" sz="900" b="1" dirty="0">
+                <a:solidFill>
+                  <a:srgbClr val="0F172A"/>
+                </a:solidFill>
+                <a:latin typeface="Segoe UI" pitchFamily="34" charset="0"/>
+                <a:ea typeface="Segoe UI" pitchFamily="34" charset="-122"/>
+                <a:cs typeface="Segoe UI" pitchFamily="34" charset="-120"/>
+              </a:rPr>
+              <a:t>M_axis</a:t>
+            </a:r>
+            <a:pPr indent="0" marL="0">
+              <a:buNone/>
+            </a:pPr>
+            <a:r>
+              <a:rPr lang="en-US" sz="900" dirty="0">
+                <a:solidFill>
+                  <a:srgbClr val="334155"/>
+                </a:solidFill>
+                <a:latin typeface="Segoe UI" pitchFamily="34" charset="0"/>
+                <a:ea typeface="Segoe UI" pitchFamily="34" charset="-122"/>
+                <a:cs typeface="Segoe UI" pitchFamily="34" charset="-120"/>
+              </a:rPr>
+              <a:t>:</a:t>
+            </a:r>
+            <a:endParaRPr lang="en-US" sz="900" dirty="0"/>
+          </a:p>
+        </p:txBody>
+      </p:sp>
+      <p:pic>
+        <p:nvPicPr>
+          <p:cNvPr id="15" name="Image 1" descr="C:\Users\rakadu1.AHEAD\AndroidStudioProjects\RoadSense\intel\presentations\assets\generated_math\eq_m_axis_matrix.svg">    </p:cNvPr>
+          <p:cNvPicPr>
+            <a:picLocks noChangeAspect="1"/>
+          </p:cNvPicPr>
+          <p:nvPr/>
+        </p:nvPicPr>
+        <p:blipFill>
+          <a:blip r:embed="rId3">
+            <a:extLst>
+              <a:ext uri="{96DAC541-7B7A-43D3-8B79-37D633B846F1}">
+                <asvg:svgBlip xmlns:asvg="http://schemas.microsoft.com/office/drawing/2016/SVG/main" r:embed="rId4"/>
+              </a:ext>
+            </a:extLst>
+          </a:blip>
+          <a:stretch>
+            <a:fillRect/>
+          </a:stretch>
+        </p:blipFill>
+        <p:spPr>
+          <a:xfrm>
+            <a:off x="2519178" y="3931920"/>
+            <a:ext cx="1682484" cy="685800"/>
+          </a:xfrm>
+          <a:prstGeom prst="rect">
+            <a:avLst/>
+          </a:prstGeom>
+        </p:spPr>
+      </p:pic>
+      <p:sp>
+        <p:nvSpPr>
+          <p:cNvPr id="16" name="Text 12"/>
+          <p:cNvSpPr/>
+          <p:nvPr/>
+        </p:nvSpPr>
+        <p:spPr>
+          <a:xfrm>
+            <a:off x="914400" y="4754880"/>
+            <a:ext cx="4892040" cy="457200"/>
+          </a:xfrm>
+          <a:prstGeom prst="rect">
+            <a:avLst/>
+          </a:prstGeom>
+          <a:noFill/>
+          <a:ln/>
+        </p:spPr>
+        <p:txBody>
+          <a:bodyPr wrap="square" lIns="0" tIns="0" rIns="0" bIns="0" rtlCol="0" anchor="t"/>
+          <a:lstStyle/>
+          <a:p>
+            <a:pPr indent="0" marL="0">
+              <a:buNone/>
+            </a:pPr>
+            <a:r>
+              <a:rPr lang="en-US" sz="900" dirty="0">
+                <a:solidFill>
+                  <a:srgbClr val="334155"/>
+                </a:solidFill>
+                <a:latin typeface="Segoe UI" pitchFamily="34" charset="0"/>
+                <a:ea typeface="Segoe UI" pitchFamily="34" charset="-122"/>
+                <a:cs typeface="Segoe UI" pitchFamily="34" charset="-120"/>
+              </a:rPr>
+              <a:t>which maps: </a:t>
+            </a:r>
+            <a:pPr indent="0" marL="0">
+              <a:buNone/>
+            </a:pPr>
+            <a:r>
+              <a:rPr lang="en-US" sz="900" b="1" dirty="0">
+                <a:solidFill>
+                  <a:srgbClr val="1D4ED8"/>
+                </a:solidFill>
+                <a:latin typeface="Segoe UI" pitchFamily="34" charset="0"/>
+                <a:ea typeface="Segoe UI" pitchFamily="34" charset="-122"/>
+                <a:cs typeface="Segoe UI" pitchFamily="34" charset="-120"/>
+              </a:rPr>
+              <a:t>X_C = X_veh,  Y_C = -Z_veh</a:t>
+            </a:r>
+            <a:pPr indent="0" marL="0">
+              <a:buNone/>
+            </a:pPr>
+            <a:r>
+              <a:rPr lang="en-US" sz="900" dirty="0">
+                <a:solidFill>
+                  <a:srgbClr val="334155"/>
+                </a:solidFill>
+                <a:latin typeface="Segoe UI" pitchFamily="34" charset="0"/>
+                <a:ea typeface="Segoe UI" pitchFamily="34" charset="-122"/>
+                <a:cs typeface="Segoe UI" pitchFamily="34" charset="-120"/>
+              </a:rPr>
+              <a:t> (up becomes down),  </a:t>
+            </a:r>
+            <a:pPr indent="0" marL="0">
+              <a:buNone/>
+            </a:pPr>
+            <a:r>
+              <a:rPr lang="en-US" sz="900" b="1" dirty="0">
+                <a:solidFill>
+                  <a:srgbClr val="1D4ED8"/>
+                </a:solidFill>
+                <a:latin typeface="Segoe UI" pitchFamily="34" charset="0"/>
+                <a:ea typeface="Segoe UI" pitchFamily="34" charset="-122"/>
+                <a:cs typeface="Segoe UI" pitchFamily="34" charset="-120"/>
+              </a:rPr>
+              <a:t>Z_C = Y_veh</a:t>
+            </a:r>
+            <a:pPr indent="0" marL="0">
+              <a:buNone/>
+            </a:pPr>
+            <a:r>
+              <a:rPr lang="en-US" sz="900" dirty="0">
+                <a:solidFill>
+                  <a:srgbClr val="334155"/>
+                </a:solidFill>
+                <a:latin typeface="Segoe UI" pitchFamily="34" charset="0"/>
+                <a:ea typeface="Segoe UI" pitchFamily="34" charset="-122"/>
+                <a:cs typeface="Segoe UI" pitchFamily="34" charset="-120"/>
+              </a:rPr>
+              <a:t> (forward becomes optical depth).</a:t>
+            </a:r>
+            <a:endParaRPr lang="en-US" sz="900" dirty="0"/>
+          </a:p>
+        </p:txBody>
+      </p:sp>
+      <p:sp>
+        <p:nvSpPr>
+          <p:cNvPr id="17" name="Text 13"/>
+          <p:cNvSpPr/>
+          <p:nvPr/>
+        </p:nvSpPr>
+        <p:spPr>
+          <a:xfrm>
+            <a:off x="914400" y="5349240"/>
+            <a:ext cx="4892040" cy="640080"/>
+          </a:xfrm>
+          <a:prstGeom prst="rect">
+            <a:avLst/>
+          </a:prstGeom>
+          <a:noFill/>
+          <a:ln/>
+        </p:spPr>
+        <p:txBody>
+          <a:bodyPr wrap="square" lIns="0" tIns="0" rIns="0" bIns="0" rtlCol="0" anchor="t"/>
+          <a:lstStyle/>
+          <a:p>
+            <a:pPr indent="0" marL="0">
+              <a:buNone/>
+            </a:pPr>
+            <a:r>
+              <a:rPr lang="en-US" sz="850" b="1" dirty="0">
+                <a:solidFill>
+                  <a:srgbClr val="1D4ED8"/>
+                </a:solidFill>
+                <a:latin typeface="Segoe UI" pitchFamily="34" charset="0"/>
+                <a:ea typeface="Segoe UI" pitchFamily="34" charset="-122"/>
+                <a:cs typeface="Segoe UI" pitchFamily="34" charset="-120"/>
+              </a:rPr>
+              <a:t>• Zero-Calibration Rig Requirement: </a:t>
+            </a:r>
+            <a:pPr indent="0" marL="0">
+              <a:buNone/>
+            </a:pPr>
+            <a:r>
+              <a:rPr lang="en-US" sz="850" dirty="0">
+                <a:solidFill>
+                  <a:srgbClr val="334155"/>
+                </a:solidFill>
+                <a:latin typeface="Segoe UI" pitchFamily="34" charset="0"/>
+                <a:ea typeface="Segoe UI" pitchFamily="34" charset="-122"/>
+                <a:cs typeface="Segoe UI" pitchFamily="34" charset="-120"/>
+              </a:rPr>
+              <a:t>Rigid-body baseline offsets [ΔX, ΔY, ΔZ] are measured directly at installation, decoupling translation from orientation.</a:t>
+            </a:r>
+            <a:endParaRPr lang="en-US" sz="850" dirty="0"/>
+          </a:p>
+        </p:txBody>
+      </p:sp>
+      <p:sp>
+        <p:nvSpPr>
+          <p:cNvPr id="18" name="Shape 14"/>
+          <p:cNvSpPr/>
+          <p:nvPr/>
+        </p:nvSpPr>
+        <p:spPr>
+          <a:xfrm>
+            <a:off x="6199632" y="1417320"/>
+            <a:ext cx="5257800" cy="4937760"/>
           </a:xfrm>
           <a:prstGeom prst="roundRect">
             <a:avLst>
-              <a:gd name="adj" fmla="val 1165"/>
+              <a:gd name="adj" fmla="val 1111"/>
             </a:avLst>
           </a:prstGeom>
           <a:solidFill>
@@ -5487,14 +5885,14 @@
       </p:sp>
       <p:sp>
         <p:nvSpPr>
-          <p:cNvPr id="13" name="Text 11"/>
-          <p:cNvSpPr/>
-          <p:nvPr/>
-        </p:nvSpPr>
-        <p:spPr>
-          <a:xfrm>
-            <a:off x="6473952" y="1783080"/>
-            <a:ext cx="4800600" cy="4343400"/>
+          <p:cNvPr id="19" name="Text 15"/>
+          <p:cNvSpPr/>
+          <p:nvPr/>
+        </p:nvSpPr>
+        <p:spPr>
+          <a:xfrm>
+            <a:off x="6382512" y="1581912"/>
+            <a:ext cx="4892040" cy="256032"/>
           </a:xfrm>
           <a:prstGeom prst="rect">
             <a:avLst/>
@@ -5510,7 +5908,7 @@
               <a:buNone/>
             </a:pPr>
             <a:r>
-              <a:rPr lang="en-US" sz="1300" b="1" dirty="0">
+              <a:rPr lang="en-US" sz="1100" b="1" dirty="0">
                 <a:solidFill>
                   <a:srgbClr val="0284C7"/>
                 </a:solidFill>
@@ -5518,14 +5916,112 @@
                 <a:ea typeface="Segoe UI" pitchFamily="34" charset="-122"/>
                 <a:cs typeface="Segoe UI" pitchFamily="34" charset="-120"/>
               </a:rPr>
-              <a:t>Interactive Cockpit Calibration Studio
-</a:t>
-            </a:r>
-            <a:pPr indent="0" marL="0">
-              <a:buNone/>
-            </a:pPr>
-            <a:r>
-              <a:rPr lang="en-US" sz="1050" b="1" dirty="0">
+              <a:t>3. Pinhole Perspective Projection:</a:t>
+            </a:r>
+            <a:endParaRPr lang="en-US" sz="1100" dirty="0"/>
+          </a:p>
+        </p:txBody>
+      </p:sp>
+      <p:pic>
+        <p:nvPicPr>
+          <p:cNvPr id="20" name="Image 2" descr="C:\Users\rakadu1.AHEAD\AndroidStudioProjects\RoadSense\intel\presentations\assets\generated_math\eq_pinhole_matrix.svg">    </p:cNvPr>
+          <p:cNvPicPr>
+            <a:picLocks noChangeAspect="1"/>
+          </p:cNvPicPr>
+          <p:nvPr/>
+        </p:nvPicPr>
+        <p:blipFill>
+          <a:blip r:embed="rId5">
+            <a:extLst>
+              <a:ext uri="{96DAC541-7B7A-43D3-8B79-37D633B846F1}">
+                <asvg:svgBlip xmlns:asvg="http://schemas.microsoft.com/office/drawing/2016/SVG/main" r:embed="rId6"/>
+              </a:ext>
+            </a:extLst>
+          </a:blip>
+          <a:stretch>
+            <a:fillRect/>
+          </a:stretch>
+        </p:blipFill>
+        <p:spPr>
+          <a:xfrm>
+            <a:off x="7426345" y="1874520"/>
+            <a:ext cx="2804374" cy="594360"/>
+          </a:xfrm>
+          <a:prstGeom prst="rect">
+            <a:avLst/>
+          </a:prstGeom>
+        </p:spPr>
+      </p:pic>
+      <p:pic>
+        <p:nvPicPr>
+          <p:cNvPr id="21" name="Image 3" descr="C:\Users\rakadu1.AHEAD\AndroidStudioProjects\RoadSense\intel\presentations\assets\generated_math\eq_perspective_division.svg">    </p:cNvPr>
+          <p:cNvPicPr>
+            <a:picLocks noChangeAspect="1"/>
+          </p:cNvPicPr>
+          <p:nvPr/>
+        </p:nvPicPr>
+        <p:blipFill>
+          <a:blip r:embed="rId7">
+            <a:extLst>
+              <a:ext uri="{96DAC541-7B7A-43D3-8B79-37D633B846F1}">
+                <asvg:svgBlip xmlns:asvg="http://schemas.microsoft.com/office/drawing/2016/SVG/main" r:embed="rId8"/>
+              </a:ext>
+            </a:extLst>
+          </a:blip>
+          <a:stretch>
+            <a:fillRect/>
+          </a:stretch>
+        </p:blipFill>
+        <p:spPr>
+          <a:xfrm>
+            <a:off x="7530619" y="2532888"/>
+            <a:ext cx="2595826" cy="347472"/>
+          </a:xfrm>
+          <a:prstGeom prst="rect">
+            <a:avLst/>
+          </a:prstGeom>
+        </p:spPr>
+      </p:pic>
+      <p:sp>
+        <p:nvSpPr>
+          <p:cNvPr id="22" name="Text 16"/>
+          <p:cNvSpPr/>
+          <p:nvPr/>
+        </p:nvSpPr>
+        <p:spPr>
+          <a:xfrm>
+            <a:off x="6382512" y="2953512"/>
+            <a:ext cx="4892040" cy="320040"/>
+          </a:xfrm>
+          <a:prstGeom prst="rect">
+            <a:avLst/>
+          </a:prstGeom>
+          <a:noFill/>
+          <a:ln/>
+        </p:spPr>
+        <p:txBody>
+          <a:bodyPr wrap="square" lIns="0" tIns="0" rIns="0" bIns="0" rtlCol="0" anchor="t"/>
+          <a:lstStyle/>
+          <a:p>
+            <a:pPr indent="0" marL="0">
+              <a:buNone/>
+            </a:pPr>
+            <a:r>
+              <a:rPr lang="en-US" sz="850" dirty="0">
+                <a:solidFill>
+                  <a:srgbClr val="334155"/>
+                </a:solidFill>
+                <a:latin typeface="Segoe UI" pitchFamily="34" charset="0"/>
+                <a:ea typeface="Segoe UI" pitchFamily="34" charset="-122"/>
+                <a:cs typeface="Segoe UI" pitchFamily="34" charset="-120"/>
+              </a:rPr>
+              <a:t>where </a:t>
+            </a:r>
+            <a:pPr indent="0" marL="0">
+              <a:buNone/>
+            </a:pPr>
+            <a:r>
+              <a:rPr lang="en-US" sz="850" b="1" dirty="0">
                 <a:solidFill>
                   <a:srgbClr val="0F172A"/>
                 </a:solidFill>
@@ -5533,14 +6029,13 @@
                 <a:ea typeface="Segoe UI" pitchFamily="34" charset="-122"/>
                 <a:cs typeface="Segoe UI" pitchFamily="34" charset="-120"/>
               </a:rPr>
-              <a:t>1. Real-Time Fullscreen Reticle HUD:
-</a:t>
-            </a:r>
-            <a:pPr indent="0" marL="0">
-              <a:buNone/>
-            </a:pPr>
-            <a:r>
-              <a:rPr lang="en-US" sz="950" dirty="0">
+              <a:t>[fx, fy, cx, cy]</a:t>
+            </a:r>
+            <a:pPr indent="0" marL="0">
+              <a:buNone/>
+            </a:pPr>
+            <a:r>
+              <a:rPr lang="en-US" sz="850" dirty="0">
                 <a:solidFill>
                   <a:srgbClr val="334155"/>
                 </a:solidFill>
@@ -5548,14 +6043,27 @@
                 <a:ea typeface="Segoe UI" pitchFamily="34" charset="-122"/>
                 <a:cs typeface="Segoe UI" pitchFamily="34" charset="-120"/>
               </a:rPr>
-              <a:t>   • Viewfinder displays high-contrast target reticle overlay with live coordinate readouts.
-</a:t>
-            </a:r>
-            <a:pPr indent="0" marL="0">
-              <a:buNone/>
-            </a:pPr>
-            <a:r>
-              <a:rPr lang="en-US" sz="950" dirty="0">
+              <a:t> are retrieved programmatically from Android's </a:t>
+            </a:r>
+            <a:pPr indent="0" marL="0">
+              <a:buNone/>
+            </a:pPr>
+            <a:r>
+              <a:rPr lang="en-US" sz="850" b="1" dirty="0">
+                <a:solidFill>
+                  <a:srgbClr val="0284C7"/>
+                </a:solidFill>
+                <a:latin typeface="Consolas" pitchFamily="34" charset="0"/>
+                <a:ea typeface="Consolas" pitchFamily="34" charset="-122"/>
+                <a:cs typeface="Consolas" pitchFamily="34" charset="-120"/>
+              </a:rPr>
+              <a:t>CameraCharacteristics.LENS_INTRINSIC_CALIBRATION</a:t>
+            </a:r>
+            <a:pPr indent="0" marL="0">
+              <a:buNone/>
+            </a:pPr>
+            <a:r>
+              <a:rPr lang="en-US" sz="850" dirty="0">
                 <a:solidFill>
                   <a:srgbClr val="334155"/>
                 </a:solidFill>
@@ -5563,14 +6071,67 @@
                 <a:ea typeface="Segoe UI" pitchFamily="34" charset="-122"/>
                 <a:cs typeface="Segoe UI" pitchFamily="34" charset="-120"/>
               </a:rPr>
-              <a:t>   • Displays live target range (m), azimuth (°), and pixel reprojection error.
-</a:t>
-            </a:r>
-            <a:pPr indent="0" marL="0">
-              <a:buNone/>
-            </a:pPr>
-            <a:r>
-              <a:rPr lang="en-US" sz="1050" b="1" dirty="0">
+              <a:t>.</a:t>
+            </a:r>
+            <a:endParaRPr lang="en-US" sz="850" dirty="0"/>
+          </a:p>
+        </p:txBody>
+      </p:sp>
+      <p:sp>
+        <p:nvSpPr>
+          <p:cNvPr id="23" name="Text 17"/>
+          <p:cNvSpPr/>
+          <p:nvPr/>
+        </p:nvSpPr>
+        <p:spPr>
+          <a:xfrm>
+            <a:off x="6382512" y="3383280"/>
+            <a:ext cx="4892040" cy="548640"/>
+          </a:xfrm>
+          <a:prstGeom prst="rect">
+            <a:avLst/>
+          </a:prstGeom>
+          <a:noFill/>
+          <a:ln/>
+        </p:spPr>
+        <p:txBody>
+          <a:bodyPr wrap="square" lIns="0" tIns="0" rIns="0" bIns="0" rtlCol="0" anchor="t"/>
+          <a:lstStyle/>
+          <a:p>
+            <a:pPr indent="0" marL="0">
+              <a:buNone/>
+            </a:pPr>
+            <a:r>
+              <a:rPr lang="en-US" sz="1100" b="1" dirty="0">
+                <a:solidFill>
+                  <a:srgbClr val="0284C7"/>
+                </a:solidFill>
+                <a:latin typeface="Segoe UI" pitchFamily="34" charset="0"/>
+                <a:ea typeface="Segoe UI" pitchFamily="34" charset="-122"/>
+                <a:cs typeface="Segoe UI" pitchFamily="34" charset="-120"/>
+              </a:rPr>
+              <a:t>4. Closed-Form Reverse Touch Solver (O(1) Calibration):
+</a:t>
+            </a:r>
+            <a:pPr indent="0" marL="0">
+              <a:buNone/>
+            </a:pPr>
+            <a:r>
+              <a:rPr lang="en-US" sz="900" dirty="0">
+                <a:solidFill>
+                  <a:srgbClr val="334155"/>
+                </a:solidFill>
+                <a:latin typeface="Segoe UI" pitchFamily="34" charset="0"/>
+                <a:ea typeface="Segoe UI" pitchFamily="34" charset="-122"/>
+                <a:cs typeface="Segoe UI" pitchFamily="34" charset="-120"/>
+              </a:rPr>
+              <a:t>Instead of iterative non-linear optimization or checkerboards, the user taps a vehicle bounding centroid </a:t>
+            </a:r>
+            <a:pPr indent="0" marL="0">
+              <a:buNone/>
+            </a:pPr>
+            <a:r>
+              <a:rPr lang="en-US" sz="900" b="1" dirty="0">
                 <a:solidFill>
                   <a:srgbClr val="0F172A"/>
                 </a:solidFill>
@@ -5578,14 +6139,13 @@
                 <a:ea typeface="Segoe UI" pitchFamily="34" charset="-122"/>
                 <a:cs typeface="Segoe UI" pitchFamily="34" charset="-120"/>
               </a:rPr>
-              <a:t>2. Dual-Mode Manual Fine-Tuning:
-</a:t>
-            </a:r>
-            <a:pPr indent="0" marL="0">
-              <a:buNone/>
-            </a:pPr>
-            <a:r>
-              <a:rPr lang="en-US" sz="950" dirty="0">
+              <a:t>(u_tap, v_tap)</a:t>
+            </a:r>
+            <a:pPr indent="0" marL="0">
+              <a:buNone/>
+            </a:pPr>
+            <a:r>
+              <a:rPr lang="en-US" sz="900" dirty="0">
                 <a:solidFill>
                   <a:srgbClr val="334155"/>
                 </a:solidFill>
@@ -5593,14 +6153,27 @@
                 <a:ea typeface="Segoe UI" pitchFamily="34" charset="-122"/>
                 <a:cs typeface="Segoe UI" pitchFamily="34" charset="-120"/>
               </a:rPr>
-              <a:t>   • Trackpad Delta Drag: Smooth finger dragging across virtual trackpad for fine analog adjustment.
-</a:t>
-            </a:r>
-            <a:pPr indent="0" marL="0">
-              <a:buNone/>
-            </a:pPr>
-            <a:r>
-              <a:rPr lang="en-US" sz="950" dirty="0">
+              <a:t> at radar distance </a:t>
+            </a:r>
+            <a:pPr indent="0" marL="0">
+              <a:buNone/>
+            </a:pPr>
+            <a:r>
+              <a:rPr lang="en-US" sz="900" b="1" dirty="0">
+                <a:solidFill>
+                  <a:srgbClr val="0F172A"/>
+                </a:solidFill>
+                <a:latin typeface="Segoe UI" pitchFamily="34" charset="0"/>
+                <a:ea typeface="Segoe UI" pitchFamily="34" charset="-122"/>
+                <a:cs typeface="Segoe UI" pitchFamily="34" charset="-120"/>
+              </a:rPr>
+              <a:t>R</a:t>
+            </a:r>
+            <a:pPr indent="0" marL="0">
+              <a:buNone/>
+            </a:pPr>
+            <a:r>
+              <a:rPr lang="en-US" sz="900" dirty="0">
                 <a:solidFill>
                   <a:srgbClr val="334155"/>
                 </a:solidFill>
@@ -5608,29 +6181,112 @@
                 <a:ea typeface="Segoe UI" pitchFamily="34" charset="-122"/>
                 <a:cs typeface="Segoe UI" pitchFamily="34" charset="-120"/>
               </a:rPr>
-              <a:t>   • Precision Nudge Bar: Discrete step buttons (±0.1° fine, ±1.0° coarse) for pitch/yaw.
-</a:t>
-            </a:r>
-            <a:pPr indent="0" marL="0">
-              <a:buNone/>
-            </a:pPr>
-            <a:r>
-              <a:rPr lang="en-US" sz="1050" b="1" dirty="0">
-                <a:solidFill>
-                  <a:srgbClr val="0F172A"/>
-                </a:solidFill>
-                <a:latin typeface="Segoe UI" pitchFamily="34" charset="0"/>
-                <a:ea typeface="Segoe UI" pitchFamily="34" charset="-122"/>
-                <a:cs typeface="Segoe UI" pitchFamily="34" charset="-120"/>
-              </a:rPr>
-              <a:t>3. Persistent JSON Calibration Profile:
-</a:t>
-            </a:r>
-            <a:pPr indent="0" marL="0">
-              <a:buNone/>
-            </a:pPr>
-            <a:r>
-              <a:rPr lang="en-US" sz="950" dirty="0">
+              <a:t>:</a:t>
+            </a:r>
+            <a:endParaRPr lang="en-US" sz="1100" dirty="0"/>
+          </a:p>
+        </p:txBody>
+      </p:sp>
+      <p:pic>
+        <p:nvPicPr>
+          <p:cNvPr id="24" name="Image 4" descr="C:\Users\rakadu1.AHEAD\AndroidStudioProjects\RoadSense\intel\presentations\assets\generated_math\eq_norm_ray.svg">    </p:cNvPr>
+          <p:cNvPicPr>
+            <a:picLocks noChangeAspect="1"/>
+          </p:cNvPicPr>
+          <p:nvPr/>
+        </p:nvPicPr>
+        <p:blipFill>
+          <a:blip r:embed="rId9">
+            <a:extLst>
+              <a:ext uri="{96DAC541-7B7A-43D3-8B79-37D633B846F1}">
+                <asvg:svgBlip xmlns:asvg="http://schemas.microsoft.com/office/drawing/2016/SVG/main" r:embed="rId10"/>
+              </a:ext>
+            </a:extLst>
+          </a:blip>
+          <a:stretch>
+            <a:fillRect/>
+          </a:stretch>
+        </p:blipFill>
+        <p:spPr>
+          <a:xfrm>
+            <a:off x="7484811" y="3977640"/>
+            <a:ext cx="2687442" cy="347472"/>
+          </a:xfrm>
+          <a:prstGeom prst="rect">
+            <a:avLst/>
+          </a:prstGeom>
+        </p:spPr>
+      </p:pic>
+      <p:pic>
+        <p:nvPicPr>
+          <p:cNvPr id="25" name="Image 5" descr="C:\Users\rakadu1.AHEAD\AndroidStudioProjects\RoadSense\intel\presentations\assets\generated_math\eq_angle_recovery.svg">    </p:cNvPr>
+          <p:cNvPicPr>
+            <a:picLocks noChangeAspect="1"/>
+          </p:cNvPicPr>
+          <p:nvPr/>
+        </p:nvPicPr>
+        <p:blipFill>
+          <a:blip r:embed="rId11">
+            <a:extLst>
+              <a:ext uri="{96DAC541-7B7A-43D3-8B79-37D633B846F1}">
+                <asvg:svgBlip xmlns:asvg="http://schemas.microsoft.com/office/drawing/2016/SVG/main" r:embed="rId12"/>
+              </a:ext>
+            </a:extLst>
+          </a:blip>
+          <a:stretch>
+            <a:fillRect/>
+          </a:stretch>
+        </p:blipFill>
+        <p:spPr>
+          <a:xfrm>
+            <a:off x="6382512" y="4398264"/>
+            <a:ext cx="4892040" cy="329184"/>
+          </a:xfrm>
+          <a:prstGeom prst="rect">
+            <a:avLst/>
+          </a:prstGeom>
+        </p:spPr>
+      </p:pic>
+      <p:sp>
+        <p:nvSpPr>
+          <p:cNvPr id="26" name="Text 18"/>
+          <p:cNvSpPr/>
+          <p:nvPr/>
+        </p:nvSpPr>
+        <p:spPr>
+          <a:xfrm>
+            <a:off x="6382512" y="4892040"/>
+            <a:ext cx="4892040" cy="502920"/>
+          </a:xfrm>
+          <a:prstGeom prst="rect">
+            <a:avLst/>
+          </a:prstGeom>
+          <a:noFill/>
+          <a:ln/>
+        </p:spPr>
+        <p:txBody>
+          <a:bodyPr wrap="square" lIns="0" tIns="0" rIns="0" bIns="0" rtlCol="0" anchor="t"/>
+          <a:lstStyle/>
+          <a:p>
+            <a:pPr indent="0" marL="0">
+              <a:buNone/>
+            </a:pPr>
+            <a:r>
+              <a:rPr lang="en-US" sz="850" b="1" dirty="0">
+                <a:solidFill>
+                  <a:srgbClr val="15803D"/>
+                </a:solidFill>
+                <a:latin typeface="Segoe UI" pitchFamily="34" charset="0"/>
+                <a:ea typeface="Segoe UI" pitchFamily="34" charset="-122"/>
+                <a:cs typeface="Segoe UI" pitchFamily="34" charset="-120"/>
+              </a:rPr>
+              <a:t>• Instant Track Convergence: </a:t>
+            </a:r>
+            <a:pPr indent="0" marL="0">
+              <a:buNone/>
+            </a:pPr>
+            <a:r>
+              <a:rPr lang="en-US" sz="850" dirty="0">
                 <a:solidFill>
                   <a:srgbClr val="334155"/>
                 </a:solidFill>
@@ -5638,14 +6294,52 @@
                 <a:ea typeface="Segoe UI" pitchFamily="34" charset="-122"/>
                 <a:cs typeface="Segoe UI" pitchFamily="34" charset="-120"/>
               </a:rPr>
-              <a:t>   • Automatically saved to /sdcard/.../calibration/radar_camera_calib.json.
-</a:t>
-            </a:r>
-            <a:pPr indent="0" marL="0">
-              <a:buNone/>
-            </a:pPr>
-            <a:r>
-              <a:rPr lang="en-US" sz="950" dirty="0">
+              <a:t>Recovers pitch and yaw in &lt;1 ms with zero gradient descent or bundle adjustment. Guarantees instant, repeatable calibration right on the test track.</a:t>
+            </a:r>
+            <a:endParaRPr lang="en-US" sz="850" dirty="0"/>
+          </a:p>
+        </p:txBody>
+      </p:sp>
+      <p:sp>
+        <p:nvSpPr>
+          <p:cNvPr id="27" name="Text 19"/>
+          <p:cNvSpPr/>
+          <p:nvPr/>
+        </p:nvSpPr>
+        <p:spPr>
+          <a:xfrm>
+            <a:off x="6382512" y="5440680"/>
+            <a:ext cx="4892040" cy="594360"/>
+          </a:xfrm>
+          <a:prstGeom prst="rect">
+            <a:avLst/>
+          </a:prstGeom>
+          <a:noFill/>
+          <a:ln/>
+        </p:spPr>
+        <p:txBody>
+          <a:bodyPr wrap="square" lIns="0" tIns="0" rIns="0" bIns="0" rtlCol="0" anchor="t"/>
+          <a:lstStyle/>
+          <a:p>
+            <a:pPr indent="0" marL="0">
+              <a:buNone/>
+            </a:pPr>
+            <a:r>
+              <a:rPr lang="en-US" sz="850" b="1" dirty="0">
+                <a:solidFill>
+                  <a:srgbClr val="0284C7"/>
+                </a:solidFill>
+                <a:latin typeface="Segoe UI" pitchFamily="34" charset="0"/>
+                <a:ea typeface="Segoe UI" pitchFamily="34" charset="-122"/>
+                <a:cs typeface="Segoe UI" pitchFamily="34" charset="-120"/>
+              </a:rPr>
+              <a:t>• Persistent JSON &amp; Monotonic Sync: </a:t>
+            </a:r>
+            <a:pPr indent="0" marL="0">
+              <a:buNone/>
+            </a:pPr>
+            <a:r>
+              <a:rPr lang="en-US" sz="850" dirty="0">
                 <a:solidFill>
                   <a:srgbClr val="334155"/>
                 </a:solidFill>
@@ -5653,39 +6347,9 @@
                 <a:ea typeface="Segoe UI" pitchFamily="34" charset="-122"/>
                 <a:cs typeface="Segoe UI" pitchFamily="34" charset="-120"/>
               </a:rPr>
-              <a:t>   • Reloaded across app restarts and embedded into downstream session archives.
-</a:t>
-            </a:r>
-            <a:pPr indent="0" marL="0">
-              <a:buNone/>
-            </a:pPr>
-            <a:r>
-              <a:rPr lang="en-US" sz="1050" b="1" dirty="0">
-                <a:solidFill>
-                  <a:srgbClr val="0F172A"/>
-                </a:solidFill>
-                <a:latin typeface="Segoe UI" pitchFamily="34" charset="0"/>
-                <a:ea typeface="Segoe UI" pitchFamily="34" charset="-122"/>
-                <a:cs typeface="Segoe UI" pitchFamily="34" charset="-120"/>
-              </a:rPr>
-              <a:t>4. Accidental Gesture Interlock:
-</a:t>
-            </a:r>
-            <a:pPr indent="0" marL="0">
-              <a:buNone/>
-            </a:pPr>
-            <a:r>
-              <a:rPr lang="en-US" sz="950" dirty="0">
-                <a:solidFill>
-                  <a:srgbClr val="334155"/>
-                </a:solidFill>
-                <a:latin typeface="Segoe UI" pitchFamily="34" charset="0"/>
-                <a:ea typeface="Segoe UI" pitchFamily="34" charset="-122"/>
-                <a:cs typeface="Segoe UI" pitchFamily="34" charset="-120"/>
-              </a:rPr>
-              <a:t>   • Cockpit HorizontalPager userScrollEnabled = false during active calibration to prevent inadvertent tab paging while dragging reticles.</a:t>
-            </a:r>
-            <a:endParaRPr lang="en-US" sz="1300" dirty="0"/>
+              <a:t>Angles are saved to calibration/radar_camera_calib.json and attached directly to session MCAP containers for unified Foxglove playback.</a:t>
+            </a:r>
+            <a:endParaRPr lang="en-US" sz="850" dirty="0"/>
           </a:p>
         </p:txBody>
       </p:sp>
@@ -7682,7 +8346,7 @@
                 <a:ea typeface="Segoe UI" pitchFamily="34" charset="-122"/>
                 <a:cs typeface="Segoe UI" pitchFamily="34" charset="-120"/>
               </a:rPr>
-              <a:t>Zero-Dependency Local Web Server
+              <a:t>Zero-Dependency Local Web Server &amp; Automation Engine
 </a:t>
             </a:r>
             <a:pPr indent="0" marL="0">
@@ -7772,7 +8436,7 @@
                 <a:ea typeface="Segoe UI" pitchFamily="34" charset="-122"/>
                 <a:cs typeface="Segoe UI" pitchFamily="34" charset="-120"/>
               </a:rPr>
-              <a:t>   • Robust REST API endpoints for sessions, devices, extraction, and playback.
+              <a:t>   • Robust REST API endpoints (/api/status, /api/sessions, /api/run, /api/stop).
 </a:t>
             </a:r>
             <a:pPr indent="0" marL="0">
@@ -7862,15 +8526,15 @@
         <p:spPr>
           <a:xfrm>
             <a:off x="6291072" y="1600200"/>
-            <a:ext cx="5166360" cy="4709160"/>
+            <a:ext cx="5166360" cy="1325880"/>
           </a:xfrm>
           <a:prstGeom prst="roundRect">
             <a:avLst>
-              <a:gd name="adj" fmla="val 1165"/>
+              <a:gd name="adj" fmla="val 4138"/>
             </a:avLst>
           </a:prstGeom>
           <a:solidFill>
-            <a:srgbClr val="F8FAFC"/>
+            <a:srgbClr val="0F172A"/>
           </a:solidFill>
           <a:ln w="15240">
             <a:solidFill>
@@ -7888,8 +8552,8 @@
         </p:nvSpPr>
         <p:spPr>
           <a:xfrm>
-            <a:off x="6473952" y="1783080"/>
-            <a:ext cx="4800600" cy="4343400"/>
+            <a:off x="6473952" y="1737360"/>
+            <a:ext cx="4800600" cy="228600"/>
           </a:xfrm>
           <a:prstGeom prst="rect">
             <a:avLst/>
@@ -7898,29 +8562,359 @@
           <a:ln/>
         </p:spPr>
         <p:txBody>
-          <a:bodyPr wrap="square" lIns="0" tIns="0" rIns="0" bIns="0" rtlCol="0" anchor="t"/>
+          <a:bodyPr wrap="square" lIns="0" tIns="0" rIns="0" bIns="0" rtlCol="0" anchor="ctr"/>
           <a:lstStyle/>
           <a:p>
             <a:pPr indent="0" marL="0">
               <a:buNone/>
             </a:pPr>
             <a:r>
-              <a:rPr lang="en-US" sz="1300" b="1" dirty="0">
-                <a:solidFill>
-                  <a:srgbClr val="0284C7"/>
-                </a:solidFill>
-                <a:latin typeface="Segoe UI" pitchFamily="34" charset="0"/>
-                <a:ea typeface="Segoe UI" pitchFamily="34" charset="-122"/>
-                <a:cs typeface="Segoe UI" pitchFamily="34" charset="-120"/>
-              </a:rPr>
-              <a:t>Automotive Web Cockpit Features
-</a:t>
-            </a:r>
-            <a:pPr indent="0" marL="0">
-              <a:buNone/>
-            </a:pPr>
-            <a:r>
-              <a:rPr lang="en-US" sz="1050" b="1" dirty="0">
+              <a:rPr lang="en-US" sz="1000" b="1" dirty="0">
+                <a:solidFill>
+                  <a:srgbClr val="38BDF8"/>
+                </a:solidFill>
+                <a:latin typeface="Segoe UI" pitchFamily="34" charset="0"/>
+                <a:ea typeface="Segoe UI" pitchFamily="34" charset="-122"/>
+                <a:cs typeface="Segoe UI" pitchFamily="34" charset="-120"/>
+              </a:rPr>
+              <a:t>RoadSense Telemetry &amp; Script Hub  •  http://127.0.0.1:8088</a:t>
+            </a:r>
+            <a:endParaRPr lang="en-US" sz="1000" dirty="0"/>
+          </a:p>
+        </p:txBody>
+      </p:sp>
+      <p:sp>
+        <p:nvSpPr>
+          <p:cNvPr id="14" name="Shape 12"/>
+          <p:cNvSpPr/>
+          <p:nvPr/>
+        </p:nvSpPr>
+        <p:spPr>
+          <a:xfrm>
+            <a:off x="6473952" y="2039112"/>
+            <a:ext cx="2286000" cy="329184"/>
+          </a:xfrm>
+          <a:prstGeom prst="roundRect">
+            <a:avLst>
+              <a:gd name="adj" fmla="val 16667"/>
+            </a:avLst>
+          </a:prstGeom>
+          <a:solidFill>
+            <a:srgbClr val="1E293B"/>
+          </a:solidFill>
+          <a:ln w="15240">
+            <a:solidFill>
+              <a:srgbClr val="334155"/>
+            </a:solidFill>
+            <a:prstDash val="solid"/>
+          </a:ln>
+        </p:spPr>
+      </p:sp>
+      <p:sp>
+        <p:nvSpPr>
+          <p:cNvPr id="15" name="Text 13"/>
+          <p:cNvSpPr/>
+          <p:nvPr/>
+        </p:nvSpPr>
+        <p:spPr>
+          <a:xfrm>
+            <a:off x="6565392" y="2112264"/>
+            <a:ext cx="2103120" cy="182880"/>
+          </a:xfrm>
+          <a:prstGeom prst="rect">
+            <a:avLst/>
+          </a:prstGeom>
+          <a:noFill/>
+          <a:ln/>
+        </p:spPr>
+        <p:txBody>
+          <a:bodyPr wrap="square" lIns="0" tIns="0" rIns="0" bIns="0" rtlCol="0" anchor="ctr"/>
+          <a:lstStyle/>
+          <a:p>
+            <a:pPr indent="0" marL="0">
+              <a:buNone/>
+            </a:pPr>
+            <a:r>
+              <a:rPr lang="en-US" sz="800" b="1" dirty="0">
+                <a:solidFill>
+                  <a:srgbClr val="10B981"/>
+                </a:solidFill>
+                <a:latin typeface="Segoe UI" pitchFamily="34" charset="0"/>
+                <a:ea typeface="Segoe UI" pitchFamily="34" charset="-122"/>
+                <a:cs typeface="Segoe UI" pitchFamily="34" charset="-120"/>
+              </a:rPr>
+              <a:t>ADB STATUS: Connected (M21)</a:t>
+            </a:r>
+            <a:endParaRPr lang="en-US" sz="800" dirty="0"/>
+          </a:p>
+        </p:txBody>
+      </p:sp>
+      <p:sp>
+        <p:nvSpPr>
+          <p:cNvPr id="16" name="Shape 14"/>
+          <p:cNvSpPr/>
+          <p:nvPr/>
+        </p:nvSpPr>
+        <p:spPr>
+          <a:xfrm>
+            <a:off x="8897112" y="2039112"/>
+            <a:ext cx="2286000" cy="329184"/>
+          </a:xfrm>
+          <a:prstGeom prst="roundRect">
+            <a:avLst>
+              <a:gd name="adj" fmla="val 16667"/>
+            </a:avLst>
+          </a:prstGeom>
+          <a:solidFill>
+            <a:srgbClr val="1E293B"/>
+          </a:solidFill>
+          <a:ln w="15240">
+            <a:solidFill>
+              <a:srgbClr val="334155"/>
+            </a:solidFill>
+            <a:prstDash val="solid"/>
+          </a:ln>
+        </p:spPr>
+      </p:sp>
+      <p:sp>
+        <p:nvSpPr>
+          <p:cNvPr id="17" name="Text 15"/>
+          <p:cNvSpPr/>
+          <p:nvPr/>
+        </p:nvSpPr>
+        <p:spPr>
+          <a:xfrm>
+            <a:off x="8988552" y="2112264"/>
+            <a:ext cx="2103120" cy="182880"/>
+          </a:xfrm>
+          <a:prstGeom prst="rect">
+            <a:avLst/>
+          </a:prstGeom>
+          <a:noFill/>
+          <a:ln/>
+        </p:spPr>
+        <p:txBody>
+          <a:bodyPr wrap="square" lIns="0" tIns="0" rIns="0" bIns="0" rtlCol="0" anchor="ctr"/>
+          <a:lstStyle/>
+          <a:p>
+            <a:pPr indent="0" marL="0">
+              <a:buNone/>
+            </a:pPr>
+            <a:r>
+              <a:rPr lang="en-US" sz="800" b="1" dirty="0">
+                <a:solidFill>
+                  <a:srgbClr val="F59E0B"/>
+                </a:solidFill>
+                <a:latin typeface="Segoe UI" pitchFamily="34" charset="0"/>
+                <a:ea typeface="Segoe UI" pitchFamily="34" charset="-122"/>
+                <a:cs typeface="Segoe UI" pitchFamily="34" charset="-120"/>
+              </a:rPr>
+              <a:t>PHONE BATTERY: 55% • 36.2°C</a:t>
+            </a:r>
+            <a:endParaRPr lang="en-US" sz="800" dirty="0"/>
+          </a:p>
+        </p:txBody>
+      </p:sp>
+      <p:sp>
+        <p:nvSpPr>
+          <p:cNvPr id="18" name="Shape 16"/>
+          <p:cNvSpPr/>
+          <p:nvPr/>
+        </p:nvSpPr>
+        <p:spPr>
+          <a:xfrm>
+            <a:off x="6473952" y="2423160"/>
+            <a:ext cx="2286000" cy="329184"/>
+          </a:xfrm>
+          <a:prstGeom prst="roundRect">
+            <a:avLst>
+              <a:gd name="adj" fmla="val 16667"/>
+            </a:avLst>
+          </a:prstGeom>
+          <a:solidFill>
+            <a:srgbClr val="1E293B"/>
+          </a:solidFill>
+          <a:ln w="15240">
+            <a:solidFill>
+              <a:srgbClr val="334155"/>
+            </a:solidFill>
+            <a:prstDash val="solid"/>
+          </a:ln>
+        </p:spPr>
+      </p:sp>
+      <p:sp>
+        <p:nvSpPr>
+          <p:cNvPr id="19" name="Text 17"/>
+          <p:cNvSpPr/>
+          <p:nvPr/>
+        </p:nvSpPr>
+        <p:spPr>
+          <a:xfrm>
+            <a:off x="6565392" y="2496312"/>
+            <a:ext cx="2103120" cy="182880"/>
+          </a:xfrm>
+          <a:prstGeom prst="rect">
+            <a:avLst/>
+          </a:prstGeom>
+          <a:noFill/>
+          <a:ln/>
+        </p:spPr>
+        <p:txBody>
+          <a:bodyPr wrap="square" lIns="0" tIns="0" rIns="0" bIns="0" rtlCol="0" anchor="ctr"/>
+          <a:lstStyle/>
+          <a:p>
+            <a:pPr indent="0" marL="0">
+              <a:buNone/>
+            </a:pPr>
+            <a:r>
+              <a:rPr lang="en-US" sz="800" b="1" dirty="0">
+                <a:solidFill>
+                  <a:srgbClr val="38BDF8"/>
+                </a:solidFill>
+                <a:latin typeface="Segoe UI" pitchFamily="34" charset="0"/>
+                <a:ea typeface="Segoe UI" pitchFamily="34" charset="-122"/>
+                <a:cs typeface="Segoe UI" pitchFamily="34" charset="-120"/>
+              </a:rPr>
+              <a:t>PHONE STORAGE: 42.8 GB Free</a:t>
+            </a:r>
+            <a:endParaRPr lang="en-US" sz="800" dirty="0"/>
+          </a:p>
+        </p:txBody>
+      </p:sp>
+      <p:sp>
+        <p:nvSpPr>
+          <p:cNvPr id="20" name="Shape 18"/>
+          <p:cNvSpPr/>
+          <p:nvPr/>
+        </p:nvSpPr>
+        <p:spPr>
+          <a:xfrm>
+            <a:off x="8897112" y="2423160"/>
+            <a:ext cx="2286000" cy="329184"/>
+          </a:xfrm>
+          <a:prstGeom prst="roundRect">
+            <a:avLst>
+              <a:gd name="adj" fmla="val 16667"/>
+            </a:avLst>
+          </a:prstGeom>
+          <a:solidFill>
+            <a:srgbClr val="1E293B"/>
+          </a:solidFill>
+          <a:ln w="15240">
+            <a:solidFill>
+              <a:srgbClr val="334155"/>
+            </a:solidFill>
+            <a:prstDash val="solid"/>
+          </a:ln>
+        </p:spPr>
+      </p:sp>
+      <p:sp>
+        <p:nvSpPr>
+          <p:cNvPr id="21" name="Text 19"/>
+          <p:cNvSpPr/>
+          <p:nvPr/>
+        </p:nvSpPr>
+        <p:spPr>
+          <a:xfrm>
+            <a:off x="8988552" y="2496312"/>
+            <a:ext cx="2103120" cy="182880"/>
+          </a:xfrm>
+          <a:prstGeom prst="rect">
+            <a:avLst/>
+          </a:prstGeom>
+          <a:noFill/>
+          <a:ln/>
+        </p:spPr>
+        <p:txBody>
+          <a:bodyPr wrap="square" lIns="0" tIns="0" rIns="0" bIns="0" rtlCol="0" anchor="ctr"/>
+          <a:lstStyle/>
+          <a:p>
+            <a:pPr indent="0" marL="0">
+              <a:buNone/>
+            </a:pPr>
+            <a:r>
+              <a:rPr lang="en-US" sz="800" b="1" dirty="0">
+                <a:solidFill>
+                  <a:srgbClr val="A855F7"/>
+                </a:solidFill>
+                <a:latin typeface="Segoe UI" pitchFamily="34" charset="0"/>
+                <a:ea typeface="Segoe UI" pitchFamily="34" charset="-122"/>
+                <a:cs typeface="Segoe UI" pitchFamily="34" charset="-120"/>
+              </a:rPr>
+              <a:t>DESKTOP GPU: NVENC Active</a:t>
+            </a:r>
+            <a:endParaRPr lang="en-US" sz="800" dirty="0"/>
+          </a:p>
+        </p:txBody>
+      </p:sp>
+      <p:sp>
+        <p:nvSpPr>
+          <p:cNvPr id="22" name="Shape 20"/>
+          <p:cNvSpPr/>
+          <p:nvPr/>
+        </p:nvSpPr>
+        <p:spPr>
+          <a:xfrm>
+            <a:off x="6291072" y="3108960"/>
+            <a:ext cx="5166360" cy="3200400"/>
+          </a:xfrm>
+          <a:prstGeom prst="roundRect">
+            <a:avLst>
+              <a:gd name="adj" fmla="val 1714"/>
+            </a:avLst>
+          </a:prstGeom>
+          <a:solidFill>
+            <a:srgbClr val="F1F5F9"/>
+          </a:solidFill>
+          <a:ln w="19050">
+            <a:solidFill>
+              <a:srgbClr val="1D4ED8"/>
+            </a:solidFill>
+            <a:prstDash val="dash"/>
+          </a:ln>
+        </p:spPr>
+      </p:sp>
+      <p:sp>
+        <p:nvSpPr>
+          <p:cNvPr id="23" name="Text 21"/>
+          <p:cNvSpPr/>
+          <p:nvPr/>
+        </p:nvSpPr>
+        <p:spPr>
+          <a:xfrm>
+            <a:off x="6473952" y="3383280"/>
+            <a:ext cx="4800600" cy="2651760"/>
+          </a:xfrm>
+          <a:prstGeom prst="rect">
+            <a:avLst/>
+          </a:prstGeom>
+          <a:noFill/>
+          <a:ln/>
+        </p:spPr>
+        <p:txBody>
+          <a:bodyPr wrap="square" lIns="0" tIns="0" rIns="0" bIns="0" rtlCol="0" anchor="ctr"/>
+          <a:lstStyle/>
+          <a:p>
+            <a:pPr algn="ctr" indent="0" marL="0">
+              <a:buNone/>
+            </a:pPr>
+            <a:r>
+              <a:rPr lang="en-US" sz="1000" b="1" dirty="0">
+                <a:solidFill>
+                  <a:srgbClr val="1D4ED8"/>
+                </a:solidFill>
+                <a:latin typeface="Segoe UI" pitchFamily="34" charset="0"/>
+                <a:ea typeface="Segoe UI" pitchFamily="34" charset="-122"/>
+                <a:cs typeface="Segoe UI" pitchFamily="34" charset="-120"/>
+              </a:rPr>
+              <a:t>[ WEB DASHBOARD VISUAL SHOWCASE ]
+</a:t>
+            </a:r>
+            <a:pPr algn="ctr" indent="0" marL="0">
+              <a:buNone/>
+            </a:pPr>
+            <a:r>
+              <a:rPr lang="en-US" sz="1250" b="1" dirty="0">
                 <a:solidFill>
                   <a:srgbClr val="0F172A"/>
                 </a:solidFill>
@@ -7928,159 +8922,92 @@
                 <a:ea typeface="Segoe UI" pitchFamily="34" charset="-122"/>
                 <a:cs typeface="Segoe UI" pitchFamily="34" charset="-120"/>
               </a:rPr>
-              <a:t>1. Dark-Mode Automotive Cockpit:
-</a:t>
-            </a:r>
-            <a:pPr indent="0" marL="0">
+              <a:t>RoadSense Web Cockpit (http://localhost:8088)
+</a:t>
+            </a:r>
+            <a:pPr algn="ctr" indent="0" marL="0">
               <a:buNone/>
             </a:pPr>
             <a:r>
               <a:rPr lang="en-US" sz="950" dirty="0">
                 <a:solidFill>
-                  <a:srgbClr val="334155"/>
-                </a:solidFill>
-                <a:latin typeface="Segoe UI" pitchFamily="34" charset="0"/>
-                <a:ea typeface="Segoe UI" pitchFamily="34" charset="-122"/>
-                <a:cs typeface="Segoe UI" pitchFamily="34" charset="-120"/>
-              </a:rPr>
-              <a:t>   • High-contrast slate/cyan UI designed for test-track visibility and quick operation.
-</a:t>
-            </a:r>
-            <a:pPr indent="0" marL="0">
+                  <a:srgbClr val="64748B"/>
+                </a:solidFill>
+                <a:latin typeface="Segoe UI" pitchFamily="34" charset="0"/>
+                <a:ea typeface="Segoe UI" pitchFamily="34" charset="-122"/>
+                <a:cs typeface="Segoe UI" pitchFamily="34" charset="-120"/>
+              </a:rPr>
+              <a:t>Live browser cockpit interface demonstrating:</a:t>
+            </a:r>
+            <a:endParaRPr lang="en-US" sz="1000" dirty="0"/>
+          </a:p>
+          <a:p>
+            <a:pPr algn="ctr" indent="0" marL="0">
               <a:buNone/>
             </a:pPr>
             <a:r>
               <a:rPr lang="en-US" sz="950" dirty="0">
                 <a:solidFill>
-                  <a:srgbClr val="334155"/>
-                </a:solidFill>
-                <a:latin typeface="Segoe UI" pitchFamily="34" charset="0"/>
-                <a:ea typeface="Segoe UI" pitchFamily="34" charset="-122"/>
-                <a:cs typeface="Segoe UI" pitchFamily="34" charset="-120"/>
-              </a:rPr>
-              <a:t>   • Dynamic gauges for Battery (%), Thermal State (°C), and Storage (GB free).
-</a:t>
-            </a:r>
-            <a:pPr indent="0" marL="0">
-              <a:buNone/>
-            </a:pPr>
-            <a:r>
-              <a:rPr lang="en-US" sz="1050" b="1" dirty="0">
-                <a:solidFill>
-                  <a:srgbClr val="0F172A"/>
-                </a:solidFill>
-                <a:latin typeface="Segoe UI" pitchFamily="34" charset="0"/>
-                <a:ea typeface="Segoe UI" pitchFamily="34" charset="-122"/>
-                <a:cs typeface="Segoe UI" pitchFamily="34" charset="-120"/>
-              </a:rPr>
-              <a:t>2. Session Ingestion &amp; Health Inspector:
-</a:t>
-            </a:r>
-            <a:pPr indent="0" marL="0">
+                  <a:srgbClr val="64748B"/>
+                </a:solidFill>
+                <a:latin typeface="Segoe UI" pitchFamily="34" charset="0"/>
+                <a:ea typeface="Segoe UI" pitchFamily="34" charset="-122"/>
+                <a:cs typeface="Segoe UI" pitchFamily="34" charset="-120"/>
+              </a:rPr>
+              <a:t>• 1-Click ADB log extraction, verification &amp; MCAP compilation</a:t>
+            </a:r>
+            <a:endParaRPr lang="en-US" sz="1000" dirty="0"/>
+          </a:p>
+          <a:p>
+            <a:pPr algn="ctr" indent="0" marL="0">
               <a:buNone/>
             </a:pPr>
             <a:r>
               <a:rPr lang="en-US" sz="950" dirty="0">
                 <a:solidFill>
-                  <a:srgbClr val="334155"/>
-                </a:solidFill>
-                <a:latin typeface="Segoe UI" pitchFamily="34" charset="0"/>
-                <a:ea typeface="Segoe UI" pitchFamily="34" charset="-122"/>
-                <a:cs typeface="Segoe UI" pitchFamily="34" charset="-120"/>
-              </a:rPr>
-              <a:t>   • Automatically enumerates all on-device drive sessions with sensor inventories.
-</a:t>
-            </a:r>
-            <a:pPr indent="0" marL="0">
+                  <a:srgbClr val="64748B"/>
+                </a:solidFill>
+                <a:latin typeface="Segoe UI" pitchFamily="34" charset="0"/>
+                <a:ea typeface="Segoe UI" pitchFamily="34" charset="-122"/>
+                <a:cs typeface="Segoe UI" pitchFamily="34" charset="-120"/>
+              </a:rPr>
+              <a:t>• Real-time SSE progress streaming with transfer bitrates</a:t>
+            </a:r>
+            <a:endParaRPr lang="en-US" sz="1000" dirty="0"/>
+          </a:p>
+          <a:p>
+            <a:pPr algn="ctr" indent="0" marL="0">
               <a:buNone/>
             </a:pPr>
             <a:r>
               <a:rPr lang="en-US" sz="950" dirty="0">
                 <a:solidFill>
-                  <a:srgbClr val="334155"/>
-                </a:solidFill>
-                <a:latin typeface="Segoe UI" pitchFamily="34" charset="0"/>
-                <a:ea typeface="Segoe UI" pitchFamily="34" charset="-122"/>
-                <a:cs typeface="Segoe UI" pitchFamily="34" charset="-120"/>
-              </a:rPr>
-              <a:t>   • 1-Click extraction pulling Radar, Camera, IMU, GNSS, and CANedge2 logs.
-</a:t>
-            </a:r>
-            <a:pPr indent="0" marL="0">
-              <a:buNone/>
-            </a:pPr>
-            <a:r>
-              <a:rPr lang="en-US" sz="1050" b="1" dirty="0">
-                <a:solidFill>
-                  <a:srgbClr val="0F172A"/>
-                </a:solidFill>
-                <a:latin typeface="Segoe UI" pitchFamily="34" charset="0"/>
-                <a:ea typeface="Segoe UI" pitchFamily="34" charset="-122"/>
-                <a:cs typeface="Segoe UI" pitchFamily="34" charset="-120"/>
-              </a:rPr>
-              <a:t>3. Automated MCAP Conversion Pipeline:
-</a:t>
-            </a:r>
-            <a:pPr indent="0" marL="0">
+                  <a:srgbClr val="64748B"/>
+                </a:solidFill>
+                <a:latin typeface="Segoe UI" pitchFamily="34" charset="0"/>
+                <a:ea typeface="Segoe UI" pitchFamily="34" charset="-122"/>
+                <a:cs typeface="Segoe UI" pitchFamily="34" charset="-120"/>
+              </a:rPr>
+              <a:t>• Session inventory table with sensor health indicators</a:t>
+            </a:r>
+            <a:endParaRPr lang="en-US" sz="1000" dirty="0"/>
+          </a:p>
+          <a:p>
+            <a:pPr algn="ctr" indent="0" marL="0">
               <a:buNone/>
             </a:pPr>
             <a:r>
               <a:rPr lang="en-US" sz="950" dirty="0">
                 <a:solidFill>
-                  <a:srgbClr val="334155"/>
-                </a:solidFill>
-                <a:latin typeface="Segoe UI" pitchFamily="34" charset="0"/>
-                <a:ea typeface="Segoe UI" pitchFamily="34" charset="-122"/>
-                <a:cs typeface="Segoe UI" pitchFamily="34" charset="-120"/>
-              </a:rPr>
-              <a:t>   • Triggers session_to_mcap.py directly with user-selectable demuxing modes.
-</a:t>
-            </a:r>
-            <a:pPr indent="0" marL="0">
-              <a:buNone/>
-            </a:pPr>
-            <a:r>
-              <a:rPr lang="en-US" sz="950" dirty="0">
-                <a:solidFill>
-                  <a:srgbClr val="334155"/>
-                </a:solidFill>
-                <a:latin typeface="Segoe UI" pitchFamily="34" charset="0"/>
-                <a:ea typeface="Segoe UI" pitchFamily="34" charset="-122"/>
-                <a:cs typeface="Segoe UI" pitchFamily="34" charset="-120"/>
-              </a:rPr>
-              <a:t>   • Real-time progress bar tracking video demux, point cloud serialization, and /tf.
-</a:t>
-            </a:r>
-            <a:pPr indent="0" marL="0">
-              <a:buNone/>
-            </a:pPr>
-            <a:r>
-              <a:rPr lang="en-US" sz="1050" b="1" dirty="0">
-                <a:solidFill>
-                  <a:srgbClr val="0F172A"/>
-                </a:solidFill>
-                <a:latin typeface="Segoe UI" pitchFamily="34" charset="0"/>
-                <a:ea typeface="Segoe UI" pitchFamily="34" charset="-122"/>
-                <a:cs typeface="Segoe UI" pitchFamily="34" charset="-120"/>
-              </a:rPr>
-              <a:t>4. Instant 1-Click Foxglove Launcher:
-</a:t>
-            </a:r>
-            <a:pPr indent="0" marL="0">
-              <a:buNone/>
-            </a:pPr>
-            <a:r>
-              <a:rPr lang="en-US" sz="950" dirty="0">
-                <a:solidFill>
-                  <a:srgbClr val="334155"/>
-                </a:solidFill>
-                <a:latin typeface="Segoe UI" pitchFamily="34" charset="0"/>
-                <a:ea typeface="Segoe UI" pitchFamily="34" charset="-122"/>
-                <a:cs typeface="Segoe UI" pitchFamily="34" charset="-120"/>
-              </a:rPr>
-              <a:t>   • Generates direct desktop foxglove://open?ds=file URIs for instant visualization.</a:t>
-            </a:r>
-            <a:endParaRPr lang="en-US" sz="1300" dirty="0"/>
+                  <a:srgbClr val="64748B"/>
+                </a:solidFill>
+                <a:latin typeface="Segoe UI" pitchFamily="34" charset="0"/>
+                <a:ea typeface="Segoe UI" pitchFamily="34" charset="-122"/>
+                <a:cs typeface="Segoe UI" pitchFamily="34" charset="-120"/>
+              </a:rPr>
+              <a:t>• 1-Click Foxglove desktop player launcher button</a:t>
+            </a:r>
+            <a:endParaRPr lang="en-US" sz="1000" dirty="0"/>
           </a:p>
         </p:txBody>
       </p:sp>
@@ -8409,7 +9336,7 @@
         <p:spPr>
           <a:xfrm>
             <a:off x="731520" y="1600200"/>
-            <a:ext cx="10728655" cy="1874520"/>
+            <a:ext cx="5166360" cy="1874520"/>
           </a:xfrm>
           <a:prstGeom prst="roundRect">
             <a:avLst>
@@ -8436,7 +9363,7 @@
         <p:spPr>
           <a:xfrm>
             <a:off x="914400" y="1737360"/>
-            <a:ext cx="10362895" cy="1600200"/>
+            <a:ext cx="4800600" cy="1600200"/>
           </a:xfrm>
           <a:prstGeom prst="rect">
             <a:avLst/>
@@ -8452,7 +9379,7 @@
               <a:buNone/>
             </a:pPr>
             <a:r>
-              <a:rPr lang="en-US" sz="1250" b="1" dirty="0">
+              <a:rPr lang="en-US" sz="1200" b="1" dirty="0">
                 <a:solidFill>
                   <a:srgbClr val="1D4ED8"/>
                 </a:solidFill>
@@ -8460,14 +9387,14 @@
                 <a:ea typeface="Segoe UI" pitchFamily="34" charset="-122"/>
                 <a:cs typeface="Segoe UI" pitchFamily="34" charset="-120"/>
               </a:rPr>
-              <a:t>The Orientation Challenge &amp; The Zero-Cost Mathematical Breakthrough
-</a:t>
-            </a:r>
-            <a:pPr indent="0" marL="0">
-              <a:buNone/>
-            </a:pPr>
-            <a:r>
-              <a:rPr lang="en-US" sz="1000" b="1" dirty="0">
+              <a:t>Zero-Cost Mathematical /tf Frame Roll Alignment
+</a:t>
+            </a:r>
+            <a:pPr indent="0" marL="0">
+              <a:buNone/>
+            </a:pPr>
+            <a:r>
+              <a:rPr lang="en-US" sz="950" b="1" dirty="0">
                 <a:solidFill>
                   <a:srgbClr val="0F172A"/>
                 </a:solidFill>
@@ -8481,7 +9408,7 @@
               <a:buNone/>
             </a:pPr>
             <a:r>
-              <a:rPr lang="en-US" sz="950" dirty="0">
+              <a:rPr lang="en-US" sz="900" dirty="0">
                 <a:solidFill>
                   <a:srgbClr val="334155"/>
                 </a:solidFill>
@@ -8489,14 +9416,14 @@
                 <a:ea typeface="Segoe UI" pitchFamily="34" charset="-122"/>
                 <a:cs typeface="Segoe UI" pitchFamily="34" charset="-120"/>
               </a:rPr>
-              <a:t>Android smartphones mounted in landscape record H.264 video with an internal 180° rotation matrix. Previously, rendering this upright in Foxglove 3D space required full video transcoding (decoding and re-encoding every frame).
-</a:t>
-            </a:r>
-            <a:pPr indent="0" marL="0">
-              <a:buNone/>
-            </a:pPr>
-            <a:r>
-              <a:rPr lang="en-US" sz="1000" b="1" dirty="0">
+              <a:t>Android smartphones mounted in landscape record H.264 video with an internal 180° rotation matrix. Rendering this upright in 3D space previously required full video re-encoding.
+</a:t>
+            </a:r>
+            <a:pPr indent="0" marL="0">
+              <a:buNone/>
+            </a:pPr>
+            <a:r>
+              <a:rPr lang="en-US" sz="950" b="1" dirty="0">
                 <a:solidFill>
                   <a:srgbClr val="15803D"/>
                 </a:solidFill>
@@ -8510,7 +9437,7 @@
               <a:buNone/>
             </a:pPr>
             <a:r>
-              <a:rPr lang="en-US" sz="950" dirty="0">
+              <a:rPr lang="en-US" sz="900" dirty="0">
                 <a:solidFill>
                   <a:srgbClr val="334155"/>
                 </a:solidFill>
@@ -8518,14 +9445,14 @@
                 <a:ea typeface="Segoe UI" pitchFamily="34" charset="-122"/>
                 <a:cs typeface="Segoe UI" pitchFamily="34" charset="-120"/>
               </a:rPr>
-              <a:t>Instead of modifying pixel buffers, session_to_mcap.py inspects the MP4 tkhd matrix in O(1) time and automatically folds 180° into the camera_optical /tf frame roll:
-</a:t>
-            </a:r>
-            <a:pPr indent="0" marL="0">
-              <a:buNone/>
-            </a:pPr>
-            <a:r>
-              <a:rPr lang="en-US" sz="950" b="1" dirty="0">
+              <a:t>session_to_mcap.py inspects the MP4 tkhd matrix in O(1) time and folds 180° into the camera_optical /tf frame roll:
+</a:t>
+            </a:r>
+            <a:pPr indent="0" marL="0">
+              <a:buNone/>
+            </a:pPr>
+            <a:r>
+              <a:rPr lang="en-US" sz="850" b="1" dirty="0">
                 <a:solidFill>
                   <a:srgbClr val="1D4ED8"/>
                 </a:solidFill>
@@ -8540,7 +9467,7 @@
               <a:buNone/>
             </a:pPr>
             <a:r>
-              <a:rPr lang="en-US" sz="1000" b="1" dirty="0">
+              <a:rPr lang="en-US" sz="950" b="1" dirty="0">
                 <a:solidFill>
                   <a:srgbClr val="0F172A"/>
                 </a:solidFill>
@@ -8548,13 +9475,13 @@
                 <a:ea typeface="Segoe UI" pitchFamily="34" charset="-122"/>
                 <a:cs typeface="Segoe UI" pitchFamily="34" charset="-120"/>
               </a:rPr>
-              <a:t>• Embedded Cockpit Layout: </a:t>
-            </a:r>
-            <a:pPr indent="0" marL="0">
-              <a:buNone/>
-            </a:pPr>
-            <a:r>
-              <a:rPr lang="en-US" sz="950" dirty="0">
+              <a:t>• Embedded Layout: </a:t>
+            </a:r>
+            <a:pPr indent="0" marL="0">
+              <a:buNone/>
+            </a:pPr>
+            <a:r>
+              <a:rPr lang="en-US" sz="900" dirty="0">
                 <a:solidFill>
                   <a:srgbClr val="334155"/>
                 </a:solidFill>
@@ -8562,9 +9489,9 @@
                 <a:ea typeface="Segoe UI" pitchFamily="34" charset="-122"/>
                 <a:cs typeface="Segoe UI" pitchFamily="34" charset="-120"/>
               </a:rPr>
-              <a:t>Every .mcap file automatically embeds RoadSense_Cockpit_Layout.json as a container attachment for zero-setup 3D perception visualization.</a:t>
-            </a:r>
-            <a:endParaRPr lang="en-US" sz="1250" dirty="0"/>
+              <a:t>Auto-embeds RoadSense_Cockpit_Layout.json for instant 3D visualization.</a:t>
+            </a:r>
+            <a:endParaRPr lang="en-US" sz="1200" dirty="0"/>
           </a:p>
         </p:txBody>
       </p:sp>
@@ -8583,20 +9510,19 @@
           </p:nvPr>
         </p:nvGraphicFramePr>
         <p:xfrm>
-          <a:off x="731520" y="3703320"/>
-          <a:ext cx="10728655" cy="914400"/>
+          <a:off x="731520" y="3611880"/>
+          <a:ext cx="5166360" cy="914400"/>
         </p:xfrm>
         <a:graphic>
           <a:graphicData uri="http://schemas.openxmlformats.org/drawingml/2006/table">
             <a:tbl>
               <a:tblPr/>
               <a:tblGrid>
-                <a:gridCol w="2286000"/>
-                <a:gridCol w="1463040"/>
-                <a:gridCol w="1645920"/>
-                <a:gridCol w="1828800"/>
-                <a:gridCol w="1767535"/>
-                <a:gridCol w="1737360"/>
+                <a:gridCol w="1417320"/>
+                <a:gridCol w="960120"/>
+                <a:gridCol w="868680"/>
+                <a:gridCol w="960120"/>
+                <a:gridCol w="960120"/>
               </a:tblGrid>
               <a:tr h="0">
                 <a:tc>
@@ -8608,14 +9534,14 @@
                         <a:buNone/>
                       </a:pPr>
                       <a:r>
-                        <a:rPr lang="en-US" sz="950" b="1" dirty="0">
+                        <a:rPr lang="en-US" sz="850" b="1" dirty="0">
                           <a:solidFill>
                             <a:srgbClr val="FFFFFF"/>
                           </a:solidFill>
                         </a:rPr>
                         <a:t>Conversion Mode</a:t>
                       </a:r>
-                      <a:endParaRPr lang="en-US" sz="950" dirty="0"/>
+                      <a:endParaRPr lang="en-US" sz="850" dirty="0"/>
                     </a:p>
                   </a:txBody>
                   <a:tcPr marL="91440" marR="91440" marT="45720" marB="45720" anchor="ctr">
@@ -8669,14 +9595,14 @@
                         <a:buNone/>
                       </a:pPr>
                       <a:r>
-                        <a:rPr lang="en-US" sz="950" b="1" dirty="0">
+                        <a:rPr lang="en-US" sz="850" b="1" dirty="0">
                           <a:solidFill>
                             <a:srgbClr val="FFFFFF"/>
                           </a:solidFill>
                         </a:rPr>
                         <a:t>Processing Speed</a:t>
                       </a:r>
-                      <a:endParaRPr lang="en-US" sz="950" dirty="0"/>
+                      <a:endParaRPr lang="en-US" sz="850" dirty="0"/>
                     </a:p>
                   </a:txBody>
                   <a:tcPr marL="91440" marR="91440" marT="45720" marB="45720" anchor="ctr">
@@ -8730,14 +9656,14 @@
                         <a:buNone/>
                       </a:pPr>
                       <a:r>
-                        <a:rPr lang="en-US" sz="950" b="1" dirty="0">
+                        <a:rPr lang="en-US" sz="850" b="1" dirty="0">
                           <a:solidFill>
                             <a:srgbClr val="FFFFFF"/>
                           </a:solidFill>
                         </a:rPr>
-                        <a:t>1-Min Video Duration</a:t>
+                        <a:t>1-Min Video</a:t>
                       </a:r>
-                      <a:endParaRPr lang="en-US" sz="950" dirty="0"/>
+                      <a:endParaRPr lang="en-US" sz="850" dirty="0"/>
                     </a:p>
                   </a:txBody>
                   <a:tcPr marL="91440" marR="91440" marT="45720" marB="45720" anchor="ctr">
@@ -8791,14 +9717,14 @@
                         <a:buNone/>
                       </a:pPr>
                       <a:r>
-                        <a:rPr lang="en-US" sz="950" b="1" dirty="0">
+                        <a:rPr lang="en-US" sz="850" b="1" dirty="0">
                           <a:solidFill>
                             <a:srgbClr val="FFFFFF"/>
                           </a:solidFill>
                         </a:rPr>
-                        <a:t>GPU / Hardware Load</a:t>
+                        <a:t>GPU Load</a:t>
                       </a:r>
-                      <a:endParaRPr lang="en-US" sz="950" dirty="0"/>
+                      <a:endParaRPr lang="en-US" sz="850" dirty="0"/>
                     </a:p>
                   </a:txBody>
                   <a:tcPr marL="91440" marR="91440" marT="45720" marB="45720" anchor="ctr">
@@ -8852,75 +9778,14 @@
                         <a:buNone/>
                       </a:pPr>
                       <a:r>
-                        <a:rPr lang="en-US" sz="950" b="1" dirty="0">
+                        <a:rPr lang="en-US" sz="850" b="1" dirty="0">
                           <a:solidFill>
                             <a:srgbClr val="FFFFFF"/>
                           </a:solidFill>
                         </a:rPr>
-                        <a:t>Image Bitstream Quality</a:t>
+                        <a:t>Bitstream Quality</a:t>
                       </a:r>
-                      <a:endParaRPr lang="en-US" sz="950" dirty="0"/>
-                    </a:p>
-                  </a:txBody>
-                  <a:tcPr marL="91440" marR="91440" marT="45720" marB="45720" anchor="ctr">
-                    <a:lnL w="12700" cap="flat" cmpd="sng" algn="ctr">
-                      <a:solidFill>
-                        <a:srgbClr val="CBD5E1"/>
-                      </a:solidFill>
-                      <a:prstDash val="solid"/>
-                      <a:round/>
-                      <a:headEnd type="none" w="med" len="med"/>
-                      <a:tailEnd type="none" w="med" len="med"/>
-                    </a:lnL>
-                    <a:lnR w="12700" cap="flat" cmpd="sng" algn="ctr">
-                      <a:solidFill>
-                        <a:srgbClr val="CBD5E1"/>
-                      </a:solidFill>
-                      <a:prstDash val="solid"/>
-                      <a:round/>
-                      <a:headEnd type="none" w="med" len="med"/>
-                      <a:tailEnd type="none" w="med" len="med"/>
-                    </a:lnR>
-                    <a:lnT w="12700" cap="flat" cmpd="sng" algn="ctr">
-                      <a:solidFill>
-                        <a:srgbClr val="CBD5E1"/>
-                      </a:solidFill>
-                      <a:prstDash val="solid"/>
-                      <a:round/>
-                      <a:headEnd type="none" w="med" len="med"/>
-                      <a:tailEnd type="none" w="med" len="med"/>
-                    </a:lnT>
-                    <a:lnB w="12700" cap="flat" cmpd="sng" algn="ctr">
-                      <a:solidFill>
-                        <a:srgbClr val="CBD5E1"/>
-                      </a:solidFill>
-                      <a:prstDash val="solid"/>
-                      <a:round/>
-                      <a:headEnd type="none" w="med" len="med"/>
-                      <a:tailEnd type="none" w="med" len="med"/>
-                    </a:lnB>
-                    <a:solidFill>
-                      <a:srgbClr val="1E293B"/>
-                    </a:solidFill>
-                  </a:tcPr>
-                </a:tc>
-                <a:tc>
-                  <a:txBody>
-                    <a:bodyPr/>
-                    <a:lstStyle/>
-                    <a:p>
-                      <a:pPr indent="0" marL="0">
-                        <a:buNone/>
-                      </a:pPr>
-                      <a:r>
-                        <a:rPr lang="en-US" sz="950" b="1" dirty="0">
-                          <a:solidFill>
-                            <a:srgbClr val="FFFFFF"/>
-                          </a:solidFill>
-                        </a:rPr>
-                        <a:t>Recommended Use Case</a:t>
-                      </a:r>
-                      <a:endParaRPr lang="en-US" sz="950" dirty="0"/>
+                      <a:endParaRPr lang="en-US" sz="850" dirty="0"/>
                     </a:p>
                   </a:txBody>
                   <a:tcPr marL="91440" marR="91440" marT="45720" marB="45720" anchor="ctr">
@@ -8976,14 +9841,14 @@
                         <a:buNone/>
                       </a:pPr>
                       <a:r>
-                        <a:rPr lang="en-US" sz="900" b="1" dirty="0">
+                        <a:rPr lang="en-US" sz="800" b="1" dirty="0">
                           <a:solidFill>
                             <a:srgbClr val="15803D"/>
                           </a:solidFill>
                         </a:rPr>
                         <a:t>Zero-Cost Demux (Default)</a:t>
                       </a:r>
-                      <a:endParaRPr lang="en-US" sz="900" dirty="0"/>
+                      <a:endParaRPr lang="en-US" sz="800" dirty="0"/>
                     </a:p>
                   </a:txBody>
                   <a:tcPr marL="91440" marR="91440" marT="45720" marB="45720" anchor="ctr">
@@ -9037,14 +9902,14 @@
                         <a:buNone/>
                       </a:pPr>
                       <a:r>
-                        <a:rPr lang="en-US" sz="900" b="1" dirty="0">
+                        <a:rPr lang="en-US" sz="800" b="1" dirty="0">
                           <a:solidFill>
                             <a:srgbClr val="15803D"/>
                           </a:solidFill>
                         </a:rPr>
                         <a:t>&gt;11,500 FPS</a:t>
                       </a:r>
-                      <a:endParaRPr lang="en-US" sz="900" dirty="0"/>
+                      <a:endParaRPr lang="en-US" sz="800" dirty="0"/>
                     </a:p>
                   </a:txBody>
                   <a:tcPr marL="91440" marR="91440" marT="45720" marB="45720" anchor="ctr">
@@ -9098,14 +9963,14 @@
                         <a:buNone/>
                       </a:pPr>
                       <a:r>
-                        <a:rPr lang="en-US" sz="900" b="1" dirty="0">
+                        <a:rPr lang="en-US" sz="800" b="1" dirty="0">
                           <a:solidFill>
                             <a:srgbClr val="15803D"/>
                           </a:solidFill>
                         </a:rPr>
                         <a:t>~3.4 seconds</a:t>
                       </a:r>
-                      <a:endParaRPr lang="en-US" sz="900" dirty="0"/>
+                      <a:endParaRPr lang="en-US" sz="800" dirty="0"/>
                     </a:p>
                   </a:txBody>
                   <a:tcPr marL="91440" marR="91440" marT="45720" marB="45720" anchor="ctr">
@@ -9159,14 +10024,14 @@
                         <a:buNone/>
                       </a:pPr>
                       <a:r>
-                        <a:rPr lang="en-US" sz="900" dirty="0">
+                        <a:rPr lang="en-US" sz="800" dirty="0">
                           <a:solidFill>
                             <a:srgbClr val="334155"/>
                           </a:solidFill>
                         </a:rPr>
-                        <a:t>0% GPU (Minimal CPU)</a:t>
+                        <a:t>0% GPU (Low CPU)</a:t>
                       </a:r>
-                      <a:endParaRPr lang="en-US" sz="900" dirty="0"/>
+                      <a:endParaRPr lang="en-US" sz="800" dirty="0"/>
                     </a:p>
                   </a:txBody>
                   <a:tcPr marL="91440" marR="91440" marT="45720" marB="45720" anchor="ctr">
@@ -9220,75 +10085,14 @@
                         <a:buNone/>
                       </a:pPr>
                       <a:r>
-                        <a:rPr lang="en-US" sz="900" dirty="0">
+                        <a:rPr lang="en-US" sz="800" dirty="0">
                           <a:solidFill>
                             <a:srgbClr val="334155"/>
                           </a:solidFill>
                         </a:rPr>
                         <a:t>100% Bit-Lossless Copy</a:t>
                       </a:r>
-                      <a:endParaRPr lang="en-US" sz="900" dirty="0"/>
-                    </a:p>
-                  </a:txBody>
-                  <a:tcPr marL="91440" marR="91440" marT="45720" marB="45720" anchor="ctr">
-                    <a:lnL w="12700" cap="flat" cmpd="sng" algn="ctr">
-                      <a:solidFill>
-                        <a:srgbClr val="CBD5E1"/>
-                      </a:solidFill>
-                      <a:prstDash val="solid"/>
-                      <a:round/>
-                      <a:headEnd type="none" w="med" len="med"/>
-                      <a:tailEnd type="none" w="med" len="med"/>
-                    </a:lnL>
-                    <a:lnR w="12700" cap="flat" cmpd="sng" algn="ctr">
-                      <a:solidFill>
-                        <a:srgbClr val="CBD5E1"/>
-                      </a:solidFill>
-                      <a:prstDash val="solid"/>
-                      <a:round/>
-                      <a:headEnd type="none" w="med" len="med"/>
-                      <a:tailEnd type="none" w="med" len="med"/>
-                    </a:lnR>
-                    <a:lnT w="12700" cap="flat" cmpd="sng" algn="ctr">
-                      <a:solidFill>
-                        <a:srgbClr val="CBD5E1"/>
-                      </a:solidFill>
-                      <a:prstDash val="solid"/>
-                      <a:round/>
-                      <a:headEnd type="none" w="med" len="med"/>
-                      <a:tailEnd type="none" w="med" len="med"/>
-                    </a:lnT>
-                    <a:lnB w="12700" cap="flat" cmpd="sng" algn="ctr">
-                      <a:solidFill>
-                        <a:srgbClr val="CBD5E1"/>
-                      </a:solidFill>
-                      <a:prstDash val="solid"/>
-                      <a:round/>
-                      <a:headEnd type="none" w="med" len="med"/>
-                      <a:tailEnd type="none" w="med" len="med"/>
-                    </a:lnB>
-                    <a:solidFill>
-                      <a:srgbClr val="F8FAFC"/>
-                    </a:solidFill>
-                  </a:tcPr>
-                </a:tc>
-                <a:tc>
-                  <a:txBody>
-                    <a:bodyPr/>
-                    <a:lstStyle/>
-                    <a:p>
-                      <a:pPr indent="0" marL="0">
-                        <a:buNone/>
-                      </a:pPr>
-                      <a:r>
-                        <a:rPr lang="en-US" sz="900" dirty="0">
-                          <a:solidFill>
-                            <a:srgbClr val="334155"/>
-                          </a:solidFill>
-                        </a:rPr>
-                        <a:t>Default high-throughput archiving pipeline</a:t>
-                      </a:r>
-                      <a:endParaRPr lang="en-US" sz="900" dirty="0"/>
+                      <a:endParaRPr lang="en-US" sz="800" dirty="0"/>
                     </a:p>
                   </a:txBody>
                   <a:tcPr marL="91440" marR="91440" marT="45720" marB="45720" anchor="ctr">
@@ -9344,14 +10148,14 @@
                         <a:buNone/>
                       </a:pPr>
                       <a:r>
-                        <a:rPr lang="en-US" sz="900" b="1" dirty="0">
+                        <a:rPr lang="en-US" sz="800" b="1" dirty="0">
                           <a:solidFill>
                             <a:srgbClr val="1D4ED8"/>
                           </a:solidFill>
                         </a:rPr>
-                        <a:t>NVENC Transcoding (--flip-video)</a:t>
+                        <a:t>NVENC Transcode (--flip-video)</a:t>
                       </a:r>
-                      <a:endParaRPr lang="en-US" sz="900" dirty="0"/>
+                      <a:endParaRPr lang="en-US" sz="800" dirty="0"/>
                     </a:p>
                   </a:txBody>
                   <a:tcPr marL="91440" marR="91440" marT="45720" marB="45720" anchor="ctr">
@@ -9405,14 +10209,14 @@
                         <a:buNone/>
                       </a:pPr>
                       <a:r>
-                        <a:rPr lang="en-US" sz="900" b="1" dirty="0">
+                        <a:rPr lang="en-US" sz="800" b="1" dirty="0">
                           <a:solidFill>
                             <a:srgbClr val="1D4ED8"/>
                           </a:solidFill>
                         </a:rPr>
                         <a:t>~650 FPS</a:t>
                       </a:r>
-                      <a:endParaRPr lang="en-US" sz="900" dirty="0"/>
+                      <a:endParaRPr lang="en-US" sz="800" dirty="0"/>
                     </a:p>
                   </a:txBody>
                   <a:tcPr marL="91440" marR="91440" marT="45720" marB="45720" anchor="ctr">
@@ -9466,14 +10270,14 @@
                         <a:buNone/>
                       </a:pPr>
                       <a:r>
-                        <a:rPr lang="en-US" sz="900" b="1" dirty="0">
+                        <a:rPr lang="en-US" sz="800" b="1" dirty="0">
                           <a:solidFill>
                             <a:srgbClr val="1D4ED8"/>
                           </a:solidFill>
                         </a:rPr>
                         <a:t>~32 seconds</a:t>
                       </a:r>
-                      <a:endParaRPr lang="en-US" sz="900" dirty="0"/>
+                      <a:endParaRPr lang="en-US" sz="800" dirty="0"/>
                     </a:p>
                   </a:txBody>
                   <a:tcPr marL="91440" marR="91440" marT="45720" marB="45720" anchor="ctr">
@@ -9527,14 +10331,14 @@
                         <a:buNone/>
                       </a:pPr>
                       <a:r>
-                        <a:rPr lang="en-US" sz="900" dirty="0">
+                        <a:rPr lang="en-US" sz="800" dirty="0">
                           <a:solidFill>
                             <a:srgbClr val="334155"/>
                           </a:solidFill>
                         </a:rPr>
-                        <a:t>Dedicated NVENC SIP block</a:t>
+                        <a:t>NVENC Dedicated Block</a:t>
                       </a:r>
-                      <a:endParaRPr lang="en-US" sz="900" dirty="0"/>
+                      <a:endParaRPr lang="en-US" sz="800" dirty="0"/>
                     </a:p>
                   </a:txBody>
                   <a:tcPr marL="91440" marR="91440" marT="45720" marB="45720" anchor="ctr">
@@ -9588,75 +10392,14 @@
                         <a:buNone/>
                       </a:pPr>
                       <a:r>
-                        <a:rPr lang="en-US" sz="900" dirty="0">
+                        <a:rPr lang="en-US" sz="800" dirty="0">
                           <a:solidFill>
                             <a:srgbClr val="334155"/>
                           </a:solidFill>
                         </a:rPr>
                         <a:t>High-Bitrate (GOP 30 / IDR)</a:t>
                       </a:r>
-                      <a:endParaRPr lang="en-US" sz="900" dirty="0"/>
-                    </a:p>
-                  </a:txBody>
-                  <a:tcPr marL="91440" marR="91440" marT="45720" marB="45720" anchor="ctr">
-                    <a:lnL w="12700" cap="flat" cmpd="sng" algn="ctr">
-                      <a:solidFill>
-                        <a:srgbClr val="CBD5E1"/>
-                      </a:solidFill>
-                      <a:prstDash val="solid"/>
-                      <a:round/>
-                      <a:headEnd type="none" w="med" len="med"/>
-                      <a:tailEnd type="none" w="med" len="med"/>
-                    </a:lnL>
-                    <a:lnR w="12700" cap="flat" cmpd="sng" algn="ctr">
-                      <a:solidFill>
-                        <a:srgbClr val="CBD5E1"/>
-                      </a:solidFill>
-                      <a:prstDash val="solid"/>
-                      <a:round/>
-                      <a:headEnd type="none" w="med" len="med"/>
-                      <a:tailEnd type="none" w="med" len="med"/>
-                    </a:lnR>
-                    <a:lnT w="12700" cap="flat" cmpd="sng" algn="ctr">
-                      <a:solidFill>
-                        <a:srgbClr val="CBD5E1"/>
-                      </a:solidFill>
-                      <a:prstDash val="solid"/>
-                      <a:round/>
-                      <a:headEnd type="none" w="med" len="med"/>
-                      <a:tailEnd type="none" w="med" len="med"/>
-                    </a:lnT>
-                    <a:lnB w="12700" cap="flat" cmpd="sng" algn="ctr">
-                      <a:solidFill>
-                        <a:srgbClr val="CBD5E1"/>
-                      </a:solidFill>
-                      <a:prstDash val="solid"/>
-                      <a:round/>
-                      <a:headEnd type="none" w="med" len="med"/>
-                      <a:tailEnd type="none" w="med" len="med"/>
-                    </a:lnB>
-                    <a:solidFill>
-                      <a:srgbClr val="F8FAFC"/>
-                    </a:solidFill>
-                  </a:tcPr>
-                </a:tc>
-                <a:tc>
-                  <a:txBody>
-                    <a:bodyPr/>
-                    <a:lstStyle/>
-                    <a:p>
-                      <a:pPr indent="0" marL="0">
-                        <a:buNone/>
-                      </a:pPr>
-                      <a:r>
-                        <a:rPr lang="en-US" sz="900" dirty="0">
-                          <a:solidFill>
-                            <a:srgbClr val="334155"/>
-                          </a:solidFill>
-                        </a:rPr>
-                        <a:t>3rd-party viewers lacking /tf roll support</a:t>
-                      </a:r>
-                      <a:endParaRPr lang="en-US" sz="900" dirty="0"/>
+                      <a:endParaRPr lang="en-US" sz="800" dirty="0"/>
                     </a:p>
                   </a:txBody>
                   <a:tcPr marL="91440" marR="91440" marT="45720" marB="45720" anchor="ctr">
@@ -9712,14 +10455,14 @@
                         <a:buNone/>
                       </a:pPr>
                       <a:r>
-                        <a:rPr lang="en-US" sz="900" dirty="0">
+                        <a:rPr lang="en-US" sz="800" dirty="0">
                           <a:solidFill>
                             <a:srgbClr val="64748B"/>
                           </a:solidFill>
                         </a:rPr>
-                        <a:t>CPU Software Transcoding</a:t>
+                        <a:t>CPU Software Transcode</a:t>
                       </a:r>
-                      <a:endParaRPr lang="en-US" sz="900" dirty="0"/>
+                      <a:endParaRPr lang="en-US" sz="800" dirty="0"/>
                     </a:p>
                   </a:txBody>
                   <a:tcPr marL="91440" marR="91440" marT="45720" marB="45720" anchor="ctr">
@@ -9773,14 +10516,14 @@
                         <a:buNone/>
                       </a:pPr>
                       <a:r>
-                        <a:rPr lang="en-US" sz="900" dirty="0">
+                        <a:rPr lang="en-US" sz="800" dirty="0">
                           <a:solidFill>
                             <a:srgbClr val="64748B"/>
                           </a:solidFill>
                         </a:rPr>
                         <a:t>~85 FPS</a:t>
                       </a:r>
-                      <a:endParaRPr lang="en-US" sz="900" dirty="0"/>
+                      <a:endParaRPr lang="en-US" sz="800" dirty="0"/>
                     </a:p>
                   </a:txBody>
                   <a:tcPr marL="91440" marR="91440" marT="45720" marB="45720" anchor="ctr">
@@ -9834,14 +10577,14 @@
                         <a:buNone/>
                       </a:pPr>
                       <a:r>
-                        <a:rPr lang="en-US" sz="900" dirty="0">
+                        <a:rPr lang="en-US" sz="800" dirty="0">
                           <a:solidFill>
                             <a:srgbClr val="64748B"/>
                           </a:solidFill>
                         </a:rPr>
                         <a:t>~240 seconds</a:t>
                       </a:r>
-                      <a:endParaRPr lang="en-US" sz="900" dirty="0"/>
+                      <a:endParaRPr lang="en-US" sz="800" dirty="0"/>
                     </a:p>
                   </a:txBody>
                   <a:tcPr marL="91440" marR="91440" marT="45720" marB="45720" anchor="ctr">
@@ -9895,14 +10638,14 @@
                         <a:buNone/>
                       </a:pPr>
                       <a:r>
-                        <a:rPr lang="en-US" sz="900" dirty="0">
+                        <a:rPr lang="en-US" sz="800" dirty="0">
                           <a:solidFill>
                             <a:srgbClr val="64748B"/>
                           </a:solidFill>
                         </a:rPr>
-                        <a:t>100% Multi-Core CPU Load</a:t>
+                        <a:t>100% Multi-Core CPU</a:t>
                       </a:r>
-                      <a:endParaRPr lang="en-US" sz="900" dirty="0"/>
+                      <a:endParaRPr lang="en-US" sz="800" dirty="0"/>
                     </a:p>
                   </a:txBody>
                   <a:tcPr marL="91440" marR="91440" marT="45720" marB="45720" anchor="ctr">
@@ -9956,75 +10699,14 @@
                         <a:buNone/>
                       </a:pPr>
                       <a:r>
-                        <a:rPr lang="en-US" sz="900" dirty="0">
+                        <a:rPr lang="en-US" sz="800" dirty="0">
                           <a:solidFill>
                             <a:srgbClr val="64748B"/>
                           </a:solidFill>
                         </a:rPr>
-                        <a:t>Standard libx264 profile</a:t>
+                        <a:t>libx264 profile</a:t>
                       </a:r>
-                      <a:endParaRPr lang="en-US" sz="900" dirty="0"/>
-                    </a:p>
-                  </a:txBody>
-                  <a:tcPr marL="91440" marR="91440" marT="45720" marB="45720" anchor="ctr">
-                    <a:lnL w="12700" cap="flat" cmpd="sng" algn="ctr">
-                      <a:solidFill>
-                        <a:srgbClr val="CBD5E1"/>
-                      </a:solidFill>
-                      <a:prstDash val="solid"/>
-                      <a:round/>
-                      <a:headEnd type="none" w="med" len="med"/>
-                      <a:tailEnd type="none" w="med" len="med"/>
-                    </a:lnL>
-                    <a:lnR w="12700" cap="flat" cmpd="sng" algn="ctr">
-                      <a:solidFill>
-                        <a:srgbClr val="CBD5E1"/>
-                      </a:solidFill>
-                      <a:prstDash val="solid"/>
-                      <a:round/>
-                      <a:headEnd type="none" w="med" len="med"/>
-                      <a:tailEnd type="none" w="med" len="med"/>
-                    </a:lnR>
-                    <a:lnT w="12700" cap="flat" cmpd="sng" algn="ctr">
-                      <a:solidFill>
-                        <a:srgbClr val="CBD5E1"/>
-                      </a:solidFill>
-                      <a:prstDash val="solid"/>
-                      <a:round/>
-                      <a:headEnd type="none" w="med" len="med"/>
-                      <a:tailEnd type="none" w="med" len="med"/>
-                    </a:lnT>
-                    <a:lnB w="12700" cap="flat" cmpd="sng" algn="ctr">
-                      <a:solidFill>
-                        <a:srgbClr val="CBD5E1"/>
-                      </a:solidFill>
-                      <a:prstDash val="solid"/>
-                      <a:round/>
-                      <a:headEnd type="none" w="med" len="med"/>
-                      <a:tailEnd type="none" w="med" len="med"/>
-                    </a:lnB>
-                    <a:solidFill>
-                      <a:srgbClr val="F8FAFC"/>
-                    </a:solidFill>
-                  </a:tcPr>
-                </a:tc>
-                <a:tc>
-                  <a:txBody>
-                    <a:bodyPr/>
-                    <a:lstStyle/>
-                    <a:p>
-                      <a:pPr indent="0" marL="0">
-                        <a:buNone/>
-                      </a:pPr>
-                      <a:r>
-                        <a:rPr lang="en-US" sz="900" dirty="0">
-                          <a:solidFill>
-                            <a:srgbClr val="64748B"/>
-                          </a:solidFill>
-                        </a:rPr>
-                        <a:t>Fallback for non-NVIDIA test machines</a:t>
-                      </a:r>
-                      <a:endParaRPr lang="en-US" sz="900" dirty="0"/>
+                      <a:endParaRPr lang="en-US" sz="800" dirty="0"/>
                     </a:p>
                   </a:txBody>
                   <a:tcPr marL="91440" marR="91440" marT="45720" marB="45720" anchor="ctr">
@@ -10082,12 +10764,12 @@
         </p:nvSpPr>
         <p:spPr>
           <a:xfrm>
-            <a:off x="731520" y="5532120"/>
-            <a:ext cx="10728655" cy="685800"/>
+            <a:off x="731520" y="5486400"/>
+            <a:ext cx="5166360" cy="822960"/>
           </a:xfrm>
           <a:prstGeom prst="roundRect">
             <a:avLst>
-              <a:gd name="adj" fmla="val 8000"/>
+              <a:gd name="adj" fmla="val 6667"/>
             </a:avLst>
           </a:prstGeom>
           <a:solidFill>
@@ -10109,8 +10791,8 @@
         </p:nvSpPr>
         <p:spPr>
           <a:xfrm>
-            <a:off x="914400" y="5577840"/>
-            <a:ext cx="10362895" cy="594360"/>
+            <a:off x="868680" y="5532120"/>
+            <a:ext cx="4892040" cy="731520"/>
           </a:xfrm>
           <a:prstGeom prst="rect">
             <a:avLst/>
@@ -10126,7 +10808,7 @@
               <a:buNone/>
             </a:pPr>
             <a:r>
-              <a:rPr lang="en-US" sz="950" b="1" dirty="0">
+              <a:rPr lang="en-US" sz="900" b="1" dirty="0">
                 <a:solidFill>
                   <a:srgbClr val="1D4ED8"/>
                 </a:solidFill>
@@ -10134,13 +10816,13 @@
                 <a:ea typeface="Segoe UI" pitchFamily="34" charset="-122"/>
                 <a:cs typeface="Segoe UI" pitchFamily="34" charset="-120"/>
               </a:rPr>
-              <a:t>ARCHITECTURAL RESULT: </a:t>
-            </a:r>
-            <a:pPr indent="0" marL="0">
-              <a:buNone/>
-            </a:pPr>
-            <a:r>
-              <a:rPr lang="en-US" sz="900" dirty="0">
+              <a:t>PERFORMANCE MULTIPLIER: </a:t>
+            </a:r>
+            <a:pPr indent="0" marL="0">
+              <a:buNone/>
+            </a:pPr>
+            <a:r>
+              <a:rPr lang="en-US" sz="850" dirty="0">
                 <a:solidFill>
                   <a:srgbClr val="334155"/>
                 </a:solidFill>
@@ -10148,9 +10830,173 @@
                 <a:ea typeface="Segoe UI" pitchFamily="34" charset="-122"/>
                 <a:cs typeface="Segoe UI" pitchFamily="34" charset="-120"/>
               </a:rPr>
-              <a:t>Zero-cost demuxing delivers a 9.4x speedup over hardware NVENC and a 70x speedup over CPU transcoding, allowing field engineers to convert 1-hour multi-sensor drive runs in under 3.5 minutes on standard laptops.</a:t>
-            </a:r>
-            <a:endParaRPr lang="en-US" sz="950" dirty="0"/>
+              <a:t>Zero-cost demuxing delivers a 9.4x speedup over NVENC and 70x over CPU encoding, converting 1-hour sessions in under 3.5 minutes on standard laptops.</a:t>
+            </a:r>
+            <a:endParaRPr lang="en-US" sz="900" dirty="0"/>
+          </a:p>
+        </p:txBody>
+      </p:sp>
+      <p:sp>
+        <p:nvSpPr>
+          <p:cNvPr id="15" name="Shape 12"/>
+          <p:cNvSpPr/>
+          <p:nvPr/>
+        </p:nvSpPr>
+        <p:spPr>
+          <a:xfrm>
+            <a:off x="6291072" y="1600200"/>
+            <a:ext cx="5166360" cy="4709160"/>
+          </a:xfrm>
+          <a:prstGeom prst="roundRect">
+            <a:avLst>
+              <a:gd name="adj" fmla="val 1165"/>
+            </a:avLst>
+          </a:prstGeom>
+          <a:solidFill>
+            <a:srgbClr val="F1F5F9"/>
+          </a:solidFill>
+          <a:ln w="19050">
+            <a:solidFill>
+              <a:srgbClr val="1D4ED8"/>
+            </a:solidFill>
+            <a:prstDash val="dash"/>
+          </a:ln>
+        </p:spPr>
+      </p:sp>
+      <p:sp>
+        <p:nvSpPr>
+          <p:cNvPr id="16" name="Text 13"/>
+          <p:cNvSpPr/>
+          <p:nvPr/>
+        </p:nvSpPr>
+        <p:spPr>
+          <a:xfrm>
+            <a:off x="6473952" y="1874520"/>
+            <a:ext cx="4800600" cy="4160520"/>
+          </a:xfrm>
+          <a:prstGeom prst="rect">
+            <a:avLst/>
+          </a:prstGeom>
+          <a:noFill/>
+          <a:ln/>
+        </p:spPr>
+        <p:txBody>
+          <a:bodyPr wrap="square" lIns="0" tIns="0" rIns="0" bIns="0" rtlCol="0" anchor="ctr"/>
+          <a:lstStyle/>
+          <a:p>
+            <a:pPr algn="ctr" indent="0" marL="0">
+              <a:buNone/>
+            </a:pPr>
+            <a:r>
+              <a:rPr lang="en-US" sz="1000" b="1" dirty="0">
+                <a:solidFill>
+                  <a:srgbClr val="1D4ED8"/>
+                </a:solidFill>
+                <a:latin typeface="Segoe UI" pitchFamily="34" charset="0"/>
+                <a:ea typeface="Segoe UI" pitchFamily="34" charset="-122"/>
+                <a:cs typeface="Segoe UI" pitchFamily="34" charset="-120"/>
+              </a:rPr>
+              <a:t>[ FOXGLOVE 3D PERCEPTION SHOWCASE ]
+</a:t>
+            </a:r>
+            <a:pPr algn="ctr" indent="0" marL="0">
+              <a:buNone/>
+            </a:pPr>
+            <a:r>
+              <a:rPr lang="en-US" sz="1250" b="1" dirty="0">
+                <a:solidFill>
+                  <a:srgbClr val="0F172A"/>
+                </a:solidFill>
+                <a:latin typeface="Segoe UI" pitchFamily="34" charset="0"/>
+                <a:ea typeface="Segoe UI" pitchFamily="34" charset="-122"/>
+                <a:cs typeface="Segoe UI" pitchFamily="34" charset="-120"/>
+              </a:rPr>
+              <a:t>Foxglove Studio 3D Perception Cockpit
+</a:t>
+            </a:r>
+            <a:pPr algn="ctr" indent="0" marL="0">
+              <a:buNone/>
+            </a:pPr>
+            <a:r>
+              <a:rPr lang="en-US" sz="950" dirty="0">
+                <a:solidFill>
+                  <a:srgbClr val="64748B"/>
+                </a:solidFill>
+                <a:latin typeface="Segoe UI" pitchFamily="34" charset="0"/>
+                <a:ea typeface="Segoe UI" pitchFamily="34" charset="-122"/>
+                <a:cs typeface="Segoe UI" pitchFamily="34" charset="-120"/>
+              </a:rPr>
+              <a:t>Embedded RoadSense_Cockpit_Layout.json:</a:t>
+            </a:r>
+            <a:endParaRPr lang="en-US" sz="1000" dirty="0"/>
+          </a:p>
+          <a:p>
+            <a:pPr algn="ctr" indent="0" marL="0">
+              <a:buNone/>
+            </a:pPr>
+            <a:r>
+              <a:rPr lang="en-US" sz="950" dirty="0">
+                <a:solidFill>
+                  <a:srgbClr val="64748B"/>
+                </a:solidFill>
+                <a:latin typeface="Segoe UI" pitchFamily="34" charset="0"/>
+                <a:ea typeface="Segoe UI" pitchFamily="34" charset="-122"/>
+                <a:cs typeface="Segoe UI" pitchFamily="34" charset="-120"/>
+              </a:rPr>
+              <a:t>• Upright 1080p camera feed with /tf optical roll alignment</a:t>
+            </a:r>
+            <a:endParaRPr lang="en-US" sz="1000" dirty="0"/>
+          </a:p>
+          <a:p>
+            <a:pPr algn="ctr" indent="0" marL="0">
+              <a:buNone/>
+            </a:pPr>
+            <a:r>
+              <a:rPr lang="en-US" sz="950" dirty="0">
+                <a:solidFill>
+                  <a:srgbClr val="64748B"/>
+                </a:solidFill>
+                <a:latin typeface="Segoe UI" pitchFamily="34" charset="0"/>
+                <a:ea typeface="Segoe UI" pitchFamily="34" charset="-122"/>
+                <a:cs typeface="Segoe UI" pitchFamily="34" charset="-120"/>
+              </a:rPr>
+              <a:t>• 3D TI mmWave radar point cloud &amp; Doppler velocity vectors</a:t>
+            </a:r>
+            <a:endParaRPr lang="en-US" sz="1000" dirty="0"/>
+          </a:p>
+          <a:p>
+            <a:pPr algn="ctr" indent="0" marL="0">
+              <a:buNone/>
+            </a:pPr>
+            <a:r>
+              <a:rPr lang="en-US" sz="950" dirty="0">
+                <a:solidFill>
+                  <a:srgbClr val="64748B"/>
+                </a:solidFill>
+                <a:latin typeface="Segoe UI" pitchFamily="34" charset="0"/>
+                <a:ea typeface="Segoe UI" pitchFamily="34" charset="-122"/>
+                <a:cs typeface="Segoe UI" pitchFamily="34" charset="-120"/>
+              </a:rPr>
+              <a:t>• Persistent target tracks with velocity vectors &amp; bounding boxes</a:t>
+            </a:r>
+            <a:endParaRPr lang="en-US" sz="1000" dirty="0"/>
+          </a:p>
+          <a:p>
+            <a:pPr algn="ctr" indent="0" marL="0">
+              <a:buNone/>
+            </a:pPr>
+            <a:r>
+              <a:rPr lang="en-US" sz="950" dirty="0">
+                <a:solidFill>
+                  <a:srgbClr val="64748B"/>
+                </a:solidFill>
+                <a:latin typeface="Segoe UI" pitchFamily="34" charset="0"/>
+                <a:ea typeface="Segoe UI" pitchFamily="34" charset="-122"/>
+                <a:cs typeface="Segoe UI" pitchFamily="34" charset="-120"/>
+              </a:rPr>
+              <a:t>• Monotonic timeline scrubber with synchronized multi-sensor playback</a:t>
+            </a:r>
+            <a:endParaRPr lang="en-US" sz="1000" dirty="0"/>
           </a:p>
         </p:txBody>
       </p:sp>

</xml_diff>